<commit_message>
error rasgos Bombuscaro, outliers, graphs
</commit_message>
<xml_diff>
--- a/NUMEX_pre_RStudio/NUMEX results.pptx
+++ b/NUMEX_pre_RStudio/NUMEX results.pptx
@@ -5,7 +5,7 @@
     <p:sldMasterId id="2147483648" r:id="rId1"/>
   </p:sldMasterIdLst>
   <p:notesMasterIdLst>
-    <p:notesMasterId r:id="rId32"/>
+    <p:notesMasterId r:id="rId31"/>
   </p:notesMasterIdLst>
   <p:sldIdLst>
     <p:sldId id="266" r:id="rId2"/>
@@ -19,25 +19,24 @@
     <p:sldId id="269" r:id="rId10"/>
     <p:sldId id="272" r:id="rId11"/>
     <p:sldId id="259" r:id="rId12"/>
-    <p:sldId id="286" r:id="rId13"/>
-    <p:sldId id="287" r:id="rId14"/>
-    <p:sldId id="284" r:id="rId15"/>
-    <p:sldId id="261" r:id="rId16"/>
-    <p:sldId id="260" r:id="rId17"/>
-    <p:sldId id="273" r:id="rId18"/>
-    <p:sldId id="274" r:id="rId19"/>
-    <p:sldId id="275" r:id="rId20"/>
-    <p:sldId id="288" r:id="rId21"/>
-    <p:sldId id="276" r:id="rId22"/>
-    <p:sldId id="277" r:id="rId23"/>
-    <p:sldId id="281" r:id="rId24"/>
-    <p:sldId id="278" r:id="rId25"/>
-    <p:sldId id="289" r:id="rId26"/>
-    <p:sldId id="290" r:id="rId27"/>
-    <p:sldId id="270" r:id="rId28"/>
-    <p:sldId id="257" r:id="rId29"/>
-    <p:sldId id="256" r:id="rId30"/>
-    <p:sldId id="280" r:id="rId31"/>
+    <p:sldId id="287" r:id="rId13"/>
+    <p:sldId id="284" r:id="rId14"/>
+    <p:sldId id="261" r:id="rId15"/>
+    <p:sldId id="260" r:id="rId16"/>
+    <p:sldId id="273" r:id="rId17"/>
+    <p:sldId id="274" r:id="rId18"/>
+    <p:sldId id="275" r:id="rId19"/>
+    <p:sldId id="288" r:id="rId20"/>
+    <p:sldId id="276" r:id="rId21"/>
+    <p:sldId id="277" r:id="rId22"/>
+    <p:sldId id="281" r:id="rId23"/>
+    <p:sldId id="278" r:id="rId24"/>
+    <p:sldId id="289" r:id="rId25"/>
+    <p:sldId id="290" r:id="rId26"/>
+    <p:sldId id="270" r:id="rId27"/>
+    <p:sldId id="257" r:id="rId28"/>
+    <p:sldId id="256" r:id="rId29"/>
+    <p:sldId id="280" r:id="rId30"/>
   </p:sldIdLst>
   <p:sldSz cx="12192000" cy="6858000"/>
   <p:notesSz cx="6858000" cy="9144000"/>
@@ -634,17 +633,47 @@
           <a:lstStyle/>
           <a:p>
             <a:r>
-              <a:rPr lang="es-MX" dirty="0" smtClean="0"/>
-              <a:t>U </a:t>
-            </a:r>
-            <a:r>
               <a:rPr lang="es-MX" dirty="0" err="1" smtClean="0"/>
-              <a:t>shaped</a:t>
-            </a:r>
-            <a:r>
-              <a:rPr lang="es-MX" dirty="0" smtClean="0"/>
+              <a:t>Not</a:t>
+            </a:r>
+            <a:r>
+              <a:rPr lang="es-MX" baseline="0" dirty="0" smtClean="0"/>
+              <a:t> </a:t>
+            </a:r>
+            <a:r>
+              <a:rPr lang="es-MX" baseline="0" dirty="0" err="1" smtClean="0"/>
+              <a:t>sure</a:t>
+            </a:r>
+            <a:r>
+              <a:rPr lang="es-MX" baseline="0" dirty="0" smtClean="0"/>
+              <a:t> </a:t>
+            </a:r>
+            <a:r>
+              <a:rPr lang="es-MX" baseline="0" dirty="0" err="1" smtClean="0"/>
+              <a:t>how</a:t>
+            </a:r>
+            <a:r>
+              <a:rPr lang="es-MX" baseline="0" dirty="0" smtClean="0"/>
+              <a:t> to </a:t>
+            </a:r>
+            <a:r>
+              <a:rPr lang="es-MX" baseline="0" dirty="0" err="1" smtClean="0"/>
+              <a:t>model</a:t>
+            </a:r>
+            <a:r>
+              <a:rPr lang="es-MX" baseline="0" dirty="0" smtClean="0"/>
+              <a:t> </a:t>
+            </a:r>
+            <a:r>
+              <a:rPr lang="es-MX" baseline="0" dirty="0" err="1" smtClean="0"/>
+              <a:t>them</a:t>
+            </a:r>
+            <a:r>
+              <a:rPr lang="es-MX" baseline="0" dirty="0" smtClean="0"/>
               <a:t>.</a:t>
             </a:r>
+          </a:p>
+          <a:p>
             <a:endParaRPr lang="en-US" dirty="0"/>
           </a:p>
         </p:txBody>
@@ -666,7 +695,7 @@
           <a:p>
             <a:fld id="{FB953BC2-43C1-4767-ADF3-5E906A4AA839}" type="slidenum">
               <a:rPr lang="en-US" smtClean="0"/>
-              <a:t>19</a:t>
+              <a:t>20</a:t>
             </a:fld>
             <a:endParaRPr lang="en-US"/>
           </a:p>
@@ -675,7 +704,7 @@
     </p:spTree>
     <p:extLst>
       <p:ext uri="{BB962C8B-B14F-4D97-AF65-F5344CB8AC3E}">
-        <p14:creationId xmlns:p14="http://schemas.microsoft.com/office/powerpoint/2010/main" val="2152417619"/>
+        <p14:creationId xmlns:p14="http://schemas.microsoft.com/office/powerpoint/2010/main" val="3661237908"/>
       </p:ext>
     </p:extLst>
   </p:cSld>
@@ -730,47 +759,9 @@
           <a:lstStyle/>
           <a:p>
             <a:r>
-              <a:rPr lang="es-MX" dirty="0" err="1" smtClean="0"/>
-              <a:t>Not</a:t>
-            </a:r>
-            <a:r>
-              <a:rPr lang="es-MX" baseline="0" dirty="0" smtClean="0"/>
-              <a:t> </a:t>
-            </a:r>
-            <a:r>
-              <a:rPr lang="es-MX" baseline="0" dirty="0" err="1" smtClean="0"/>
-              <a:t>sure</a:t>
-            </a:r>
-            <a:r>
-              <a:rPr lang="es-MX" baseline="0" dirty="0" smtClean="0"/>
-              <a:t> </a:t>
-            </a:r>
-            <a:r>
-              <a:rPr lang="es-MX" baseline="0" dirty="0" err="1" smtClean="0"/>
-              <a:t>how</a:t>
-            </a:r>
-            <a:r>
-              <a:rPr lang="es-MX" baseline="0" dirty="0" smtClean="0"/>
-              <a:t> to </a:t>
-            </a:r>
-            <a:r>
-              <a:rPr lang="es-MX" baseline="0" dirty="0" err="1" smtClean="0"/>
-              <a:t>model</a:t>
-            </a:r>
-            <a:r>
-              <a:rPr lang="es-MX" baseline="0" dirty="0" smtClean="0"/>
-              <a:t> </a:t>
-            </a:r>
-            <a:r>
-              <a:rPr lang="es-MX" baseline="0" dirty="0" err="1" smtClean="0"/>
-              <a:t>them</a:t>
-            </a:r>
-            <a:r>
-              <a:rPr lang="es-MX" baseline="0" dirty="0" smtClean="0"/>
-              <a:t>.</a:t>
-            </a:r>
-          </a:p>
-          <a:p>
+              <a:rPr lang="es-MX" dirty="0" smtClean="0"/>
+              <a:t>Con flecha errores</a:t>
+            </a:r>
             <a:endParaRPr lang="en-US" dirty="0"/>
           </a:p>
         </p:txBody>
@@ -801,7 +792,7 @@
     </p:spTree>
     <p:extLst>
       <p:ext uri="{BB962C8B-B14F-4D97-AF65-F5344CB8AC3E}">
-        <p14:creationId xmlns:p14="http://schemas.microsoft.com/office/powerpoint/2010/main" val="3661237908"/>
+        <p14:creationId xmlns:p14="http://schemas.microsoft.com/office/powerpoint/2010/main" val="3928284802"/>
       </p:ext>
     </p:extLst>
   </p:cSld>
@@ -857,7 +848,95 @@
           <a:p>
             <a:r>
               <a:rPr lang="es-MX" dirty="0" smtClean="0"/>
-              <a:t>Con flecha errores</a:t>
+              <a:t>Clear </a:t>
+            </a:r>
+            <a:r>
+              <a:rPr lang="es-MX" dirty="0" err="1" smtClean="0"/>
+              <a:t>differences</a:t>
+            </a:r>
+            <a:r>
+              <a:rPr lang="es-MX" dirty="0" smtClean="0"/>
+              <a:t> </a:t>
+            </a:r>
+            <a:r>
+              <a:rPr lang="es-MX" dirty="0" err="1" smtClean="0"/>
+              <a:t>between</a:t>
+            </a:r>
+            <a:r>
+              <a:rPr lang="es-MX" dirty="0" smtClean="0"/>
+              <a:t> </a:t>
+            </a:r>
+            <a:r>
+              <a:rPr lang="es-MX" dirty="0" err="1" smtClean="0"/>
+              <a:t>elevations</a:t>
+            </a:r>
+            <a:r>
+              <a:rPr lang="es-MX" dirty="0" smtClean="0"/>
+              <a:t>. </a:t>
+            </a:r>
+            <a:r>
+              <a:rPr lang="es-MX" dirty="0" err="1" smtClean="0"/>
+              <a:t>Higher</a:t>
+            </a:r>
+            <a:r>
+              <a:rPr lang="es-MX" dirty="0" smtClean="0"/>
+              <a:t> O18 </a:t>
+            </a:r>
+            <a:r>
+              <a:rPr lang="es-MX" dirty="0" err="1" smtClean="0"/>
+              <a:t>enrichment</a:t>
+            </a:r>
+            <a:r>
+              <a:rPr lang="es-MX" dirty="0" smtClean="0"/>
+              <a:t> in </a:t>
+            </a:r>
+            <a:r>
+              <a:rPr lang="es-MX" dirty="0" err="1" smtClean="0"/>
+              <a:t>the</a:t>
+            </a:r>
+            <a:r>
+              <a:rPr lang="es-MX" dirty="0" smtClean="0"/>
+              <a:t> </a:t>
+            </a:r>
+            <a:r>
+              <a:rPr lang="es-MX" dirty="0" err="1" smtClean="0"/>
+              <a:t>lowlands</a:t>
+            </a:r>
+            <a:r>
+              <a:rPr lang="es-MX" dirty="0" smtClean="0"/>
+              <a:t> and at 2000 m – </a:t>
+            </a:r>
+            <a:r>
+              <a:rPr lang="es-MX" dirty="0" err="1" smtClean="0"/>
+              <a:t>associated</a:t>
+            </a:r>
+            <a:r>
+              <a:rPr lang="es-MX" dirty="0" smtClean="0"/>
+              <a:t> </a:t>
+            </a:r>
+            <a:r>
+              <a:rPr lang="es-MX" dirty="0" err="1" smtClean="0"/>
+              <a:t>with</a:t>
+            </a:r>
+            <a:r>
+              <a:rPr lang="es-MX" dirty="0" smtClean="0"/>
+              <a:t> </a:t>
+            </a:r>
+            <a:r>
+              <a:rPr lang="es-MX" dirty="0" err="1" smtClean="0"/>
+              <a:t>higher</a:t>
+            </a:r>
+            <a:r>
+              <a:rPr lang="es-MX" dirty="0" smtClean="0"/>
+              <a:t> </a:t>
+            </a:r>
+            <a:r>
+              <a:rPr lang="es-MX" dirty="0" err="1" smtClean="0"/>
+              <a:t>transpiration</a:t>
+            </a:r>
+            <a:r>
+              <a:rPr lang="es-MX" dirty="0" smtClean="0"/>
+              <a:t>. </a:t>
             </a:r>
             <a:endParaRPr lang="en-US" dirty="0"/>
           </a:p>
@@ -880,7 +959,7 @@
           <a:p>
             <a:fld id="{FB953BC2-43C1-4767-ADF3-5E906A4AA839}" type="slidenum">
               <a:rPr lang="en-US" smtClean="0"/>
-              <a:t>22</a:t>
+              <a:t>27</a:t>
             </a:fld>
             <a:endParaRPr lang="en-US"/>
           </a:p>
@@ -889,7 +968,7 @@
     </p:spTree>
     <p:extLst>
       <p:ext uri="{BB962C8B-B14F-4D97-AF65-F5344CB8AC3E}">
-        <p14:creationId xmlns:p14="http://schemas.microsoft.com/office/powerpoint/2010/main" val="3928284802"/>
+        <p14:creationId xmlns:p14="http://schemas.microsoft.com/office/powerpoint/2010/main" val="1680979971"/>
       </p:ext>
     </p:extLst>
   </p:cSld>
@@ -944,96 +1023,180 @@
           <a:lstStyle/>
           <a:p>
             <a:r>
-              <a:rPr lang="es-MX" dirty="0" smtClean="0"/>
-              <a:t>Clear </a:t>
-            </a:r>
-            <a:r>
               <a:rPr lang="es-MX" dirty="0" err="1" smtClean="0"/>
-              <a:t>differences</a:t>
-            </a:r>
-            <a:r>
-              <a:rPr lang="es-MX" dirty="0" smtClean="0"/>
+              <a:t>Effects</a:t>
+            </a:r>
+            <a:r>
+              <a:rPr lang="es-MX" baseline="0" dirty="0" smtClean="0"/>
+              <a:t> of </a:t>
+            </a:r>
+            <a:r>
+              <a:rPr lang="es-MX" baseline="0" dirty="0" err="1" smtClean="0"/>
+              <a:t>treatment</a:t>
+            </a:r>
+            <a:r>
+              <a:rPr lang="es-MX" baseline="0" dirty="0" smtClean="0"/>
+              <a:t> in </a:t>
+            </a:r>
+            <a:r>
+              <a:rPr lang="es-MX" baseline="0" dirty="0" err="1" smtClean="0"/>
+              <a:t>Pouteria</a:t>
+            </a:r>
+            <a:r>
+              <a:rPr lang="es-MX" baseline="0" dirty="0" smtClean="0"/>
+              <a:t>, </a:t>
+            </a:r>
+            <a:r>
+              <a:rPr lang="es-MX" baseline="0" dirty="0" err="1" smtClean="0"/>
+              <a:t>Alchornea</a:t>
+            </a:r>
+            <a:r>
+              <a:rPr lang="es-MX" baseline="0" dirty="0" smtClean="0"/>
+              <a:t>, </a:t>
+            </a:r>
+            <a:r>
+              <a:rPr lang="es-MX" baseline="0" dirty="0" err="1" smtClean="0"/>
+              <a:t>Hedyosmum</a:t>
+            </a:r>
+            <a:r>
+              <a:rPr lang="es-MX" baseline="0" dirty="0" smtClean="0"/>
+              <a:t>. </a:t>
+            </a:r>
+            <a:r>
+              <a:rPr lang="es-MX" baseline="0" dirty="0" err="1" smtClean="0"/>
+              <a:t>Not</a:t>
+            </a:r>
+            <a:r>
+              <a:rPr lang="es-MX" baseline="0" dirty="0" smtClean="0"/>
               <a:t> </a:t>
             </a:r>
             <a:r>
-              <a:rPr lang="es-MX" dirty="0" err="1" smtClean="0"/>
-              <a:t>between</a:t>
-            </a:r>
-            <a:r>
-              <a:rPr lang="es-MX" dirty="0" smtClean="0"/>
+              <a:rPr lang="es-MX" baseline="0" dirty="0" err="1" smtClean="0"/>
+              <a:t>sure</a:t>
+            </a:r>
+            <a:r>
+              <a:rPr lang="es-MX" baseline="0" dirty="0" smtClean="0"/>
               <a:t> </a:t>
             </a:r>
             <a:r>
-              <a:rPr lang="es-MX" dirty="0" err="1" smtClean="0"/>
-              <a:t>elevations</a:t>
-            </a:r>
-            <a:r>
-              <a:rPr lang="es-MX" dirty="0" smtClean="0"/>
+              <a:rPr lang="es-MX" baseline="0" dirty="0" err="1" smtClean="0"/>
+              <a:t>if</a:t>
+            </a:r>
+            <a:r>
+              <a:rPr lang="es-MX" baseline="0" dirty="0" smtClean="0"/>
+              <a:t> </a:t>
+            </a:r>
+            <a:r>
+              <a:rPr lang="es-MX" baseline="0" dirty="0" err="1" smtClean="0"/>
+              <a:t>these</a:t>
+            </a:r>
+            <a:r>
+              <a:rPr lang="es-MX" baseline="0" dirty="0" smtClean="0"/>
+              <a:t> </a:t>
+            </a:r>
+            <a:r>
+              <a:rPr lang="es-MX" baseline="0" dirty="0" err="1" smtClean="0"/>
+              <a:t>graphics</a:t>
+            </a:r>
+            <a:r>
+              <a:rPr lang="es-MX" baseline="0" dirty="0" smtClean="0"/>
+              <a:t> are </a:t>
+            </a:r>
+            <a:r>
+              <a:rPr lang="es-MX" baseline="0" dirty="0" err="1" smtClean="0"/>
+              <a:t>actually</a:t>
+            </a:r>
+            <a:r>
+              <a:rPr lang="es-MX" baseline="0" dirty="0" smtClean="0"/>
+              <a:t> </a:t>
+            </a:r>
+            <a:r>
+              <a:rPr lang="es-MX" baseline="0" dirty="0" err="1" smtClean="0"/>
+              <a:t>useful</a:t>
+            </a:r>
+            <a:r>
+              <a:rPr lang="es-MX" baseline="0" dirty="0" smtClean="0"/>
               <a:t>. </a:t>
             </a:r>
             <a:r>
-              <a:rPr lang="es-MX" dirty="0" err="1" smtClean="0"/>
-              <a:t>Higher</a:t>
-            </a:r>
-            <a:r>
-              <a:rPr lang="es-MX" dirty="0" smtClean="0"/>
-              <a:t> O18 </a:t>
-            </a:r>
-            <a:r>
-              <a:rPr lang="es-MX" dirty="0" err="1" smtClean="0"/>
-              <a:t>enrichment</a:t>
-            </a:r>
-            <a:r>
-              <a:rPr lang="es-MX" dirty="0" smtClean="0"/>
-              <a:t> in </a:t>
-            </a:r>
-            <a:r>
-              <a:rPr lang="es-MX" dirty="0" err="1" smtClean="0"/>
+              <a:rPr lang="es-MX" baseline="0" dirty="0" err="1" smtClean="0"/>
+              <a:t>Dotted</a:t>
+            </a:r>
+            <a:r>
+              <a:rPr lang="es-MX" baseline="0" dirty="0" smtClean="0"/>
+              <a:t> </a:t>
+            </a:r>
+            <a:r>
+              <a:rPr lang="es-MX" baseline="0" dirty="0" err="1" smtClean="0"/>
+              <a:t>lines</a:t>
+            </a:r>
+            <a:r>
+              <a:rPr lang="es-MX" baseline="0" dirty="0" smtClean="0"/>
+              <a:t> are </a:t>
+            </a:r>
+            <a:r>
+              <a:rPr lang="es-MX" baseline="0" dirty="0" err="1" smtClean="0"/>
               <a:t>the</a:t>
             </a:r>
             <a:r>
-              <a:rPr lang="es-MX" dirty="0" smtClean="0"/>
+              <a:rPr lang="es-MX" baseline="0" dirty="0" smtClean="0"/>
               <a:t> </a:t>
             </a:r>
             <a:r>
-              <a:rPr lang="es-MX" dirty="0" err="1" smtClean="0"/>
-              <a:t>lowlands</a:t>
-            </a:r>
-            <a:r>
-              <a:rPr lang="es-MX" dirty="0" smtClean="0"/>
-              <a:t> and at 2000 m – </a:t>
-            </a:r>
-            <a:r>
-              <a:rPr lang="es-MX" dirty="0" err="1" smtClean="0"/>
-              <a:t>associated</a:t>
-            </a:r>
-            <a:r>
-              <a:rPr lang="es-MX" dirty="0" smtClean="0"/>
+              <a:rPr lang="es-MX" baseline="0" dirty="0" err="1" smtClean="0"/>
+              <a:t>means</a:t>
+            </a:r>
+            <a:r>
+              <a:rPr lang="es-MX" baseline="0" dirty="0" smtClean="0"/>
+              <a:t> of </a:t>
+            </a:r>
+            <a:r>
+              <a:rPr lang="es-MX" baseline="0" dirty="0" err="1" smtClean="0"/>
+              <a:t>the</a:t>
+            </a:r>
+            <a:r>
+              <a:rPr lang="es-MX" baseline="0" dirty="0" smtClean="0"/>
+              <a:t> control. </a:t>
+            </a:r>
+            <a:r>
+              <a:rPr lang="es-MX" baseline="0" dirty="0" err="1" smtClean="0"/>
+              <a:t>Maybe</a:t>
+            </a:r>
+            <a:r>
+              <a:rPr lang="es-MX" baseline="0" dirty="0" smtClean="0"/>
+              <a:t> I </a:t>
+            </a:r>
+            <a:r>
+              <a:rPr lang="es-MX" baseline="0" dirty="0" err="1" smtClean="0"/>
+              <a:t>should</a:t>
+            </a:r>
+            <a:r>
+              <a:rPr lang="es-MX" baseline="0" dirty="0" smtClean="0"/>
               <a:t> </a:t>
             </a:r>
             <a:r>
-              <a:rPr lang="es-MX" dirty="0" err="1" smtClean="0"/>
-              <a:t>with</a:t>
-            </a:r>
-            <a:r>
-              <a:rPr lang="es-MX" dirty="0" smtClean="0"/>
+              <a:rPr lang="es-MX" baseline="0" dirty="0" err="1" smtClean="0"/>
+              <a:t>plot</a:t>
+            </a:r>
+            <a:r>
+              <a:rPr lang="es-MX" baseline="0" dirty="0" smtClean="0"/>
               <a:t> </a:t>
             </a:r>
             <a:r>
-              <a:rPr lang="es-MX" dirty="0" err="1" smtClean="0"/>
-              <a:t>higher</a:t>
-            </a:r>
-            <a:r>
-              <a:rPr lang="es-MX" dirty="0" smtClean="0"/>
-              <a:t> </a:t>
-            </a:r>
-            <a:r>
-              <a:rPr lang="es-MX" dirty="0" err="1" smtClean="0"/>
-              <a:t>transpiration</a:t>
-            </a:r>
-            <a:r>
-              <a:rPr lang="es-MX" dirty="0" smtClean="0"/>
-              <a:t>. </a:t>
+              <a:rPr lang="es-MX" baseline="0" dirty="0" err="1" smtClean="0"/>
+              <a:t>the</a:t>
+            </a:r>
+            <a:r>
+              <a:rPr lang="es-MX" baseline="0" dirty="0" smtClean="0"/>
+              <a:t> center </a:t>
+            </a:r>
+            <a:r>
+              <a:rPr lang="es-MX" baseline="0" dirty="0" err="1" smtClean="0"/>
+              <a:t>instead</a:t>
+            </a:r>
+            <a:r>
+              <a:rPr lang="es-MX" baseline="0" dirty="0" smtClean="0"/>
+              <a:t>?</a:t>
             </a:r>
             <a:endParaRPr lang="en-US" dirty="0"/>
           </a:p>
@@ -1057,266 +1220,6 @@
             <a:fld id="{FB953BC2-43C1-4767-ADF3-5E906A4AA839}" type="slidenum">
               <a:rPr lang="en-US" smtClean="0"/>
               <a:t>28</a:t>
-            </a:fld>
-            <a:endParaRPr lang="en-US"/>
-          </a:p>
-        </p:txBody>
-      </p:sp>
-    </p:spTree>
-    <p:extLst>
-      <p:ext uri="{BB962C8B-B14F-4D97-AF65-F5344CB8AC3E}">
-        <p14:creationId xmlns:p14="http://schemas.microsoft.com/office/powerpoint/2010/main" val="1680979971"/>
-      </p:ext>
-    </p:extLst>
-  </p:cSld>
-  <p:clrMapOvr>
-    <a:masterClrMapping/>
-  </p:clrMapOvr>
-</p:notes>
-</file>
-
-<file path=ppt/notesSlides/notesSlide14.xml><?xml version="1.0" encoding="utf-8"?>
-<p:notes xmlns:a="http://schemas.openxmlformats.org/drawingml/2006/main" xmlns:r="http://schemas.openxmlformats.org/officeDocument/2006/relationships" xmlns:p="http://schemas.openxmlformats.org/presentationml/2006/main">
-  <p:cSld>
-    <p:spTree>
-      <p:nvGrpSpPr>
-        <p:cNvPr id="1" name=""/>
-        <p:cNvGrpSpPr/>
-        <p:nvPr/>
-      </p:nvGrpSpPr>
-      <p:grpSpPr>
-        <a:xfrm>
-          <a:off x="0" y="0"/>
-          <a:ext cx="0" cy="0"/>
-          <a:chOff x="0" y="0"/>
-          <a:chExt cx="0" cy="0"/>
-        </a:xfrm>
-      </p:grpSpPr>
-      <p:sp>
-        <p:nvSpPr>
-          <p:cNvPr id="2" name="Marcador de imagen de diapositiva 1"/>
-          <p:cNvSpPr>
-            <a:spLocks noGrp="1" noRot="1" noChangeAspect="1"/>
-          </p:cNvSpPr>
-          <p:nvPr>
-            <p:ph type="sldImg"/>
-          </p:nvPr>
-        </p:nvSpPr>
-        <p:spPr/>
-      </p:sp>
-      <p:sp>
-        <p:nvSpPr>
-          <p:cNvPr id="3" name="Marcador de notas 2"/>
-          <p:cNvSpPr>
-            <a:spLocks noGrp="1"/>
-          </p:cNvSpPr>
-          <p:nvPr>
-            <p:ph type="body" idx="1"/>
-          </p:nvPr>
-        </p:nvSpPr>
-        <p:spPr/>
-        <p:txBody>
-          <a:bodyPr/>
-          <a:lstStyle/>
-          <a:p>
-            <a:r>
-              <a:rPr lang="es-MX" dirty="0" err="1" smtClean="0"/>
-              <a:t>Effects</a:t>
-            </a:r>
-            <a:r>
-              <a:rPr lang="es-MX" baseline="0" dirty="0" smtClean="0"/>
-              <a:t> of </a:t>
-            </a:r>
-            <a:r>
-              <a:rPr lang="es-MX" baseline="0" dirty="0" err="1" smtClean="0"/>
-              <a:t>treatment</a:t>
-            </a:r>
-            <a:r>
-              <a:rPr lang="es-MX" baseline="0" dirty="0" smtClean="0"/>
-              <a:t> in </a:t>
-            </a:r>
-            <a:r>
-              <a:rPr lang="es-MX" baseline="0" dirty="0" err="1" smtClean="0"/>
-              <a:t>Pouteria</a:t>
-            </a:r>
-            <a:r>
-              <a:rPr lang="es-MX" baseline="0" dirty="0" smtClean="0"/>
-              <a:t>, </a:t>
-            </a:r>
-            <a:r>
-              <a:rPr lang="es-MX" baseline="0" dirty="0" err="1" smtClean="0"/>
-              <a:t>Alchornea</a:t>
-            </a:r>
-            <a:r>
-              <a:rPr lang="es-MX" baseline="0" dirty="0" smtClean="0"/>
-              <a:t>, </a:t>
-            </a:r>
-            <a:r>
-              <a:rPr lang="es-MX" baseline="0" dirty="0" err="1" smtClean="0"/>
-              <a:t>Hedyosmum</a:t>
-            </a:r>
-            <a:r>
-              <a:rPr lang="es-MX" baseline="0" dirty="0" smtClean="0"/>
-              <a:t>. </a:t>
-            </a:r>
-            <a:r>
-              <a:rPr lang="es-MX" baseline="0" dirty="0" err="1" smtClean="0"/>
-              <a:t>Not</a:t>
-            </a:r>
-            <a:r>
-              <a:rPr lang="es-MX" baseline="0" dirty="0" smtClean="0"/>
-              <a:t> </a:t>
-            </a:r>
-            <a:r>
-              <a:rPr lang="es-MX" baseline="0" dirty="0" err="1" smtClean="0"/>
-              <a:t>sure</a:t>
-            </a:r>
-            <a:r>
-              <a:rPr lang="es-MX" baseline="0" dirty="0" smtClean="0"/>
-              <a:t> </a:t>
-            </a:r>
-            <a:r>
-              <a:rPr lang="es-MX" baseline="0" dirty="0" err="1" smtClean="0"/>
-              <a:t>if</a:t>
-            </a:r>
-            <a:r>
-              <a:rPr lang="es-MX" baseline="0" dirty="0" smtClean="0"/>
-              <a:t> </a:t>
-            </a:r>
-            <a:r>
-              <a:rPr lang="es-MX" baseline="0" dirty="0" err="1" smtClean="0"/>
-              <a:t>these</a:t>
-            </a:r>
-            <a:r>
-              <a:rPr lang="es-MX" baseline="0" dirty="0" smtClean="0"/>
-              <a:t> </a:t>
-            </a:r>
-            <a:r>
-              <a:rPr lang="es-MX" baseline="0" dirty="0" err="1" smtClean="0"/>
-              <a:t>graphics</a:t>
-            </a:r>
-            <a:r>
-              <a:rPr lang="es-MX" baseline="0" dirty="0" smtClean="0"/>
-              <a:t> are </a:t>
-            </a:r>
-            <a:r>
-              <a:rPr lang="es-MX" baseline="0" dirty="0" err="1" smtClean="0"/>
-              <a:t>actually</a:t>
-            </a:r>
-            <a:r>
-              <a:rPr lang="es-MX" baseline="0" dirty="0" smtClean="0"/>
-              <a:t> </a:t>
-            </a:r>
-            <a:r>
-              <a:rPr lang="es-MX" baseline="0" dirty="0" err="1" smtClean="0"/>
-              <a:t>useful</a:t>
-            </a:r>
-            <a:r>
-              <a:rPr lang="es-MX" baseline="0" dirty="0" smtClean="0"/>
-              <a:t>. </a:t>
-            </a:r>
-            <a:r>
-              <a:rPr lang="es-MX" baseline="0" dirty="0" err="1" smtClean="0"/>
-              <a:t>Dotted</a:t>
-            </a:r>
-            <a:r>
-              <a:rPr lang="es-MX" baseline="0" dirty="0" smtClean="0"/>
-              <a:t> </a:t>
-            </a:r>
-            <a:r>
-              <a:rPr lang="es-MX" baseline="0" dirty="0" err="1" smtClean="0"/>
-              <a:t>lines</a:t>
-            </a:r>
-            <a:r>
-              <a:rPr lang="es-MX" baseline="0" dirty="0" smtClean="0"/>
-              <a:t> are </a:t>
-            </a:r>
-            <a:r>
-              <a:rPr lang="es-MX" baseline="0" dirty="0" err="1" smtClean="0"/>
-              <a:t>the</a:t>
-            </a:r>
-            <a:r>
-              <a:rPr lang="es-MX" baseline="0" dirty="0" smtClean="0"/>
-              <a:t> </a:t>
-            </a:r>
-            <a:r>
-              <a:rPr lang="es-MX" baseline="0" dirty="0" err="1" smtClean="0"/>
-              <a:t>means</a:t>
-            </a:r>
-            <a:r>
-              <a:rPr lang="es-MX" baseline="0" dirty="0" smtClean="0"/>
-              <a:t> of </a:t>
-            </a:r>
-            <a:r>
-              <a:rPr lang="es-MX" baseline="0" dirty="0" err="1" smtClean="0"/>
-              <a:t>the</a:t>
-            </a:r>
-            <a:r>
-              <a:rPr lang="es-MX" baseline="0" dirty="0" smtClean="0"/>
-              <a:t> control. </a:t>
-            </a:r>
-            <a:r>
-              <a:rPr lang="es-MX" baseline="0" dirty="0" err="1" smtClean="0"/>
-              <a:t>Maybe</a:t>
-            </a:r>
-            <a:r>
-              <a:rPr lang="es-MX" baseline="0" dirty="0" smtClean="0"/>
-              <a:t> I </a:t>
-            </a:r>
-            <a:r>
-              <a:rPr lang="es-MX" baseline="0" dirty="0" err="1" smtClean="0"/>
-              <a:t>should</a:t>
-            </a:r>
-            <a:r>
-              <a:rPr lang="es-MX" baseline="0" dirty="0" smtClean="0"/>
-              <a:t> </a:t>
-            </a:r>
-            <a:r>
-              <a:rPr lang="es-MX" baseline="0" dirty="0" err="1" smtClean="0"/>
-              <a:t>plot</a:t>
-            </a:r>
-            <a:r>
-              <a:rPr lang="es-MX" baseline="0" dirty="0" smtClean="0"/>
-              <a:t> </a:t>
-            </a:r>
-            <a:r>
-              <a:rPr lang="es-MX" baseline="0" dirty="0" err="1" smtClean="0"/>
-              <a:t>the</a:t>
-            </a:r>
-            <a:r>
-              <a:rPr lang="es-MX" baseline="0" dirty="0" smtClean="0"/>
-              <a:t> center </a:t>
-            </a:r>
-            <a:r>
-              <a:rPr lang="es-MX" baseline="0" dirty="0" err="1" smtClean="0"/>
-              <a:t>instead</a:t>
-            </a:r>
-            <a:r>
-              <a:rPr lang="es-MX" baseline="0" dirty="0" smtClean="0"/>
-              <a:t>?</a:t>
-            </a:r>
-            <a:endParaRPr lang="en-US" dirty="0"/>
-          </a:p>
-        </p:txBody>
-      </p:sp>
-      <p:sp>
-        <p:nvSpPr>
-          <p:cNvPr id="4" name="Marcador de número de diapositiva 3"/>
-          <p:cNvSpPr>
-            <a:spLocks noGrp="1"/>
-          </p:cNvSpPr>
-          <p:nvPr>
-            <p:ph type="sldNum" sz="quarter" idx="10"/>
-          </p:nvPr>
-        </p:nvSpPr>
-        <p:spPr/>
-        <p:txBody>
-          <a:bodyPr/>
-          <a:lstStyle/>
-          <a:p>
-            <a:fld id="{FB953BC2-43C1-4767-ADF3-5E906A4AA839}" type="slidenum">
-              <a:rPr lang="en-US" smtClean="0"/>
-              <a:t>29</a:t>
             </a:fld>
             <a:endParaRPr lang="en-US"/>
           </a:p>
@@ -2147,7 +2050,23 @@
           <a:p>
             <a:r>
               <a:rPr lang="es-MX" dirty="0" err="1" smtClean="0"/>
-              <a:t>The</a:t>
+              <a:t>None</a:t>
+            </a:r>
+            <a:r>
+              <a:rPr lang="es-MX" dirty="0" smtClean="0"/>
+              <a:t> of </a:t>
+            </a:r>
+            <a:r>
+              <a:rPr lang="es-MX" dirty="0" err="1" smtClean="0"/>
+              <a:t>them</a:t>
+            </a:r>
+            <a:r>
+              <a:rPr lang="es-MX" dirty="0" smtClean="0"/>
+              <a:t> are </a:t>
+            </a:r>
+            <a:r>
+              <a:rPr lang="es-MX" dirty="0" err="1" smtClean="0"/>
+              <a:t>nitrogen</a:t>
             </a:r>
             <a:r>
               <a:rPr lang="es-MX" dirty="0" smtClean="0"/>
@@ -2155,15 +2074,7 @@
             </a:r>
             <a:r>
               <a:rPr lang="es-MX" dirty="0" err="1" smtClean="0"/>
-              <a:t>dotted</a:t>
-            </a:r>
-            <a:r>
-              <a:rPr lang="es-MX" dirty="0" smtClean="0"/>
-              <a:t> line </a:t>
-            </a:r>
-            <a:r>
-              <a:rPr lang="es-MX" dirty="0" err="1" smtClean="0"/>
-              <a:t>is</a:t>
+              <a:t>fixing</a:t>
             </a:r>
             <a:r>
               <a:rPr lang="es-MX" dirty="0" smtClean="0"/>
@@ -2171,362 +2082,54 @@
             </a:r>
             <a:r>
               <a:rPr lang="es-MX" dirty="0" err="1" smtClean="0"/>
-              <a:t>the</a:t>
+              <a:t>species</a:t>
             </a:r>
             <a:r>
               <a:rPr lang="es-MX" dirty="0" smtClean="0"/>
-              <a:t> mean</a:t>
-            </a:r>
-            <a:r>
-              <a:rPr lang="es-MX" baseline="0" dirty="0" smtClean="0"/>
-              <a:t> of </a:t>
-            </a:r>
-            <a:r>
-              <a:rPr lang="es-MX" baseline="0" dirty="0" err="1" smtClean="0"/>
-              <a:t>the</a:t>
-            </a:r>
-            <a:r>
-              <a:rPr lang="es-MX" baseline="0" dirty="0" smtClean="0"/>
-              <a:t> control.  </a:t>
+              <a:t>.</a:t>
             </a:r>
           </a:p>
           <a:p>
             <a:r>
               <a:rPr lang="es-MX" dirty="0" err="1" smtClean="0"/>
-              <a:t>Weinmania</a:t>
+              <a:t>How</a:t>
             </a:r>
             <a:r>
               <a:rPr lang="es-MX" dirty="0" smtClean="0"/>
-              <a:t> looks</a:t>
-            </a:r>
-            <a:r>
-              <a:rPr lang="es-MX" baseline="0" dirty="0" smtClean="0"/>
+              <a:t> to </a:t>
+            </a:r>
+            <a:r>
+              <a:rPr lang="es-MX" dirty="0" err="1" smtClean="0"/>
+              <a:t>interpret</a:t>
+            </a:r>
+            <a:r>
+              <a:rPr lang="es-MX" dirty="0" smtClean="0"/>
               <a:t> </a:t>
             </a:r>
             <a:r>
-              <a:rPr lang="es-MX" baseline="0" dirty="0" err="1" smtClean="0"/>
-              <a:t>that</a:t>
-            </a:r>
-            <a:r>
-              <a:rPr lang="es-MX" baseline="0" dirty="0" smtClean="0"/>
-              <a:t> NP has </a:t>
-            </a:r>
-            <a:r>
-              <a:rPr lang="es-MX" baseline="0" dirty="0" err="1" smtClean="0"/>
-              <a:t>an</a:t>
-            </a:r>
-            <a:r>
-              <a:rPr lang="es-MX" baseline="0" dirty="0" smtClean="0"/>
+              <a:rPr lang="es-MX" dirty="0" err="1" smtClean="0"/>
+              <a:t>this</a:t>
+            </a:r>
+            <a:r>
+              <a:rPr lang="es-MX" dirty="0" smtClean="0"/>
               <a:t> </a:t>
             </a:r>
             <a:r>
-              <a:rPr lang="es-MX" baseline="0" dirty="0" err="1" smtClean="0"/>
-              <a:t>strong</a:t>
-            </a:r>
-            <a:r>
-              <a:rPr lang="es-MX" baseline="0" dirty="0" smtClean="0"/>
+              <a:rPr lang="es-MX" dirty="0" err="1" smtClean="0"/>
+              <a:t>one</a:t>
+            </a:r>
+            <a:r>
+              <a:rPr lang="es-MX" dirty="0" smtClean="0"/>
               <a:t> </a:t>
             </a:r>
             <a:r>
-              <a:rPr lang="es-MX" baseline="0" dirty="0" err="1" smtClean="0"/>
-              <a:t>effect</a:t>
-            </a:r>
-            <a:r>
-              <a:rPr lang="es-MX" baseline="0" dirty="0" smtClean="0"/>
-              <a:t> </a:t>
-            </a:r>
-            <a:r>
-              <a:rPr lang="es-MX" baseline="0" dirty="0" err="1" smtClean="0"/>
-              <a:t>on</a:t>
-            </a:r>
-            <a:r>
-              <a:rPr lang="es-MX" baseline="0" dirty="0" smtClean="0"/>
-              <a:t> </a:t>
-            </a:r>
-            <a:r>
-              <a:rPr lang="es-MX" baseline="0" dirty="0" err="1" smtClean="0"/>
-              <a:t>iWUE</a:t>
-            </a:r>
-            <a:r>
-              <a:rPr lang="es-MX" baseline="0" dirty="0" smtClean="0"/>
-              <a:t>, </a:t>
-            </a:r>
-            <a:r>
-              <a:rPr lang="es-MX" baseline="0" dirty="0" err="1" smtClean="0"/>
-              <a:t>but</a:t>
-            </a:r>
-            <a:r>
-              <a:rPr lang="es-MX" baseline="0" dirty="0" smtClean="0"/>
-              <a:t> </a:t>
-            </a:r>
-            <a:r>
-              <a:rPr lang="es-MX" baseline="0" dirty="0" err="1" smtClean="0"/>
-              <a:t>it</a:t>
-            </a:r>
-            <a:r>
-              <a:rPr lang="es-MX" baseline="0" dirty="0" smtClean="0"/>
-              <a:t> </a:t>
-            </a:r>
-            <a:r>
-              <a:rPr lang="es-MX" baseline="0" dirty="0" err="1" smtClean="0"/>
-              <a:t>is</a:t>
-            </a:r>
-            <a:r>
-              <a:rPr lang="es-MX" baseline="0" dirty="0" smtClean="0"/>
-              <a:t> </a:t>
-            </a:r>
-            <a:r>
-              <a:rPr lang="es-MX" baseline="0" dirty="0" err="1" smtClean="0"/>
-              <a:t>not</a:t>
-            </a:r>
-            <a:r>
-              <a:rPr lang="es-MX" baseline="0" dirty="0" smtClean="0"/>
-              <a:t> </a:t>
-            </a:r>
-            <a:r>
-              <a:rPr lang="es-MX" baseline="0" dirty="0" err="1" smtClean="0"/>
-              <a:t>statistical</a:t>
-            </a:r>
-            <a:r>
-              <a:rPr lang="es-MX" baseline="0" dirty="0" smtClean="0"/>
-              <a:t> </a:t>
-            </a:r>
-            <a:r>
-              <a:rPr lang="es-MX" baseline="0" dirty="0" err="1" smtClean="0"/>
-              <a:t>significant</a:t>
-            </a:r>
-            <a:r>
-              <a:rPr lang="es-MX" baseline="0" dirty="0" smtClean="0"/>
+              <a:rPr lang="es-MX" dirty="0" err="1" smtClean="0"/>
+              <a:t>better</a:t>
+            </a:r>
+            <a:r>
+              <a:rPr lang="es-MX" dirty="0" smtClean="0"/>
               <a:t>.</a:t>
             </a:r>
-          </a:p>
-          <a:p>
-            <a:r>
-              <a:rPr lang="es-MX" baseline="0" dirty="0" err="1" smtClean="0"/>
-              <a:t>What</a:t>
-            </a:r>
-            <a:r>
-              <a:rPr lang="es-MX" baseline="0" dirty="0" smtClean="0"/>
-              <a:t> I </a:t>
-            </a:r>
-            <a:r>
-              <a:rPr lang="es-MX" baseline="0" dirty="0" err="1" smtClean="0"/>
-              <a:t>see</a:t>
-            </a:r>
-            <a:r>
-              <a:rPr lang="es-MX" baseline="0" dirty="0" smtClean="0"/>
-              <a:t>: </a:t>
-            </a:r>
-            <a:r>
-              <a:rPr lang="es-MX" baseline="0" dirty="0" err="1" smtClean="0"/>
-              <a:t>With</a:t>
-            </a:r>
-            <a:r>
-              <a:rPr lang="es-MX" baseline="0" dirty="0" smtClean="0"/>
-              <a:t> N </a:t>
-            </a:r>
-            <a:r>
-              <a:rPr lang="es-MX" baseline="0" dirty="0" err="1" smtClean="0"/>
-              <a:t>the</a:t>
-            </a:r>
-            <a:r>
-              <a:rPr lang="es-MX" baseline="0" dirty="0" smtClean="0"/>
-              <a:t> </a:t>
-            </a:r>
-            <a:r>
-              <a:rPr lang="es-MX" baseline="0" dirty="0" err="1" smtClean="0"/>
-              <a:t>iWUE</a:t>
-            </a:r>
-            <a:r>
-              <a:rPr lang="es-MX" baseline="0" dirty="0" smtClean="0"/>
-              <a:t> </a:t>
-            </a:r>
-            <a:r>
-              <a:rPr lang="es-MX" baseline="0" dirty="0" err="1" smtClean="0"/>
-              <a:t>increases</a:t>
-            </a:r>
-            <a:r>
-              <a:rPr lang="es-MX" baseline="0" dirty="0" smtClean="0"/>
-              <a:t>, </a:t>
-            </a:r>
-            <a:r>
-              <a:rPr lang="es-MX" baseline="0" dirty="0" err="1" smtClean="0"/>
-              <a:t>with</a:t>
-            </a:r>
-            <a:r>
-              <a:rPr lang="es-MX" baseline="0" dirty="0" smtClean="0"/>
-              <a:t> P </a:t>
-            </a:r>
-            <a:r>
-              <a:rPr lang="es-MX" baseline="0" dirty="0" err="1" smtClean="0"/>
-              <a:t>iWUE</a:t>
-            </a:r>
-            <a:r>
-              <a:rPr lang="es-MX" baseline="0" dirty="0" smtClean="0"/>
-              <a:t> </a:t>
-            </a:r>
-            <a:r>
-              <a:rPr lang="es-MX" baseline="0" dirty="0" err="1" smtClean="0"/>
-              <a:t>increases</a:t>
-            </a:r>
-            <a:r>
-              <a:rPr lang="es-MX" baseline="0" dirty="0" smtClean="0"/>
-              <a:t> as </a:t>
-            </a:r>
-            <a:r>
-              <a:rPr lang="es-MX" baseline="0" dirty="0" err="1" smtClean="0"/>
-              <a:t>well</a:t>
-            </a:r>
-            <a:r>
-              <a:rPr lang="es-MX" baseline="0" dirty="0" smtClean="0"/>
-              <a:t> </a:t>
-            </a:r>
-            <a:r>
-              <a:rPr lang="es-MX" baseline="0" dirty="0" err="1" smtClean="0"/>
-              <a:t>but</a:t>
-            </a:r>
-            <a:r>
-              <a:rPr lang="es-MX" baseline="0" dirty="0" smtClean="0"/>
-              <a:t> </a:t>
-            </a:r>
-            <a:r>
-              <a:rPr lang="es-MX" baseline="0" dirty="0" err="1" smtClean="0"/>
-              <a:t>less</a:t>
-            </a:r>
-            <a:r>
-              <a:rPr lang="es-MX" baseline="0" dirty="0" smtClean="0"/>
-              <a:t> </a:t>
-            </a:r>
-            <a:r>
-              <a:rPr lang="es-MX" baseline="0" dirty="0" err="1" smtClean="0"/>
-              <a:t>strongly</a:t>
-            </a:r>
-            <a:r>
-              <a:rPr lang="es-MX" baseline="0" dirty="0" smtClean="0"/>
-              <a:t>. </a:t>
-            </a:r>
-            <a:r>
-              <a:rPr lang="es-MX" baseline="0" dirty="0" err="1" smtClean="0"/>
-              <a:t>The</a:t>
-            </a:r>
-            <a:r>
-              <a:rPr lang="es-MX" baseline="0" dirty="0" smtClean="0"/>
-              <a:t> </a:t>
-            </a:r>
-            <a:r>
-              <a:rPr lang="es-MX" baseline="0" dirty="0" err="1" smtClean="0"/>
-              <a:t>interaction</a:t>
-            </a:r>
-            <a:r>
-              <a:rPr lang="es-MX" baseline="0" dirty="0" smtClean="0"/>
-              <a:t> has a positive </a:t>
-            </a:r>
-            <a:r>
-              <a:rPr lang="es-MX" baseline="0" dirty="0" err="1" smtClean="0"/>
-              <a:t>effect</a:t>
-            </a:r>
-            <a:r>
-              <a:rPr lang="es-MX" baseline="0" dirty="0" smtClean="0"/>
-              <a:t> </a:t>
-            </a:r>
-            <a:r>
-              <a:rPr lang="es-MX" baseline="0" dirty="0" err="1" smtClean="0"/>
-              <a:t>on</a:t>
-            </a:r>
-            <a:r>
-              <a:rPr lang="es-MX" baseline="0" dirty="0" smtClean="0"/>
-              <a:t> </a:t>
-            </a:r>
-            <a:r>
-              <a:rPr lang="es-MX" baseline="0" dirty="0" err="1" smtClean="0"/>
-              <a:t>some</a:t>
-            </a:r>
-            <a:r>
-              <a:rPr lang="es-MX" baseline="0" dirty="0" smtClean="0"/>
-              <a:t> </a:t>
-            </a:r>
-            <a:r>
-              <a:rPr lang="es-MX" baseline="0" dirty="0" err="1" smtClean="0"/>
-              <a:t>species</a:t>
-            </a:r>
-            <a:r>
-              <a:rPr lang="es-MX" baseline="0" dirty="0" smtClean="0"/>
-              <a:t> (</a:t>
-            </a:r>
-            <a:r>
-              <a:rPr lang="es-MX" baseline="0" dirty="0" err="1" smtClean="0"/>
-              <a:t>Puteria</a:t>
-            </a:r>
-            <a:r>
-              <a:rPr lang="es-MX" baseline="0" dirty="0" smtClean="0"/>
-              <a:t>, </a:t>
-            </a:r>
-            <a:r>
-              <a:rPr lang="es-MX" baseline="0" dirty="0" err="1" smtClean="0"/>
-              <a:t>Myrcia</a:t>
-            </a:r>
-            <a:r>
-              <a:rPr lang="es-MX" baseline="0" dirty="0" smtClean="0"/>
-              <a:t>, </a:t>
-            </a:r>
-            <a:r>
-              <a:rPr lang="es-MX" baseline="0" dirty="0" err="1" smtClean="0"/>
-              <a:t>Hedyosmum</a:t>
-            </a:r>
-            <a:r>
-              <a:rPr lang="es-MX" baseline="0" dirty="0" smtClean="0"/>
-              <a:t>) and </a:t>
-            </a:r>
-            <a:r>
-              <a:rPr lang="es-MX" baseline="0" dirty="0" err="1" smtClean="0"/>
-              <a:t>negative</a:t>
-            </a:r>
-            <a:r>
-              <a:rPr lang="es-MX" baseline="0" dirty="0" smtClean="0"/>
-              <a:t> (</a:t>
-            </a:r>
-            <a:r>
-              <a:rPr lang="es-MX" baseline="0" dirty="0" err="1" smtClean="0"/>
-              <a:t>less</a:t>
-            </a:r>
-            <a:r>
-              <a:rPr lang="es-MX" baseline="0" dirty="0" smtClean="0"/>
-              <a:t> tan control </a:t>
-            </a:r>
-            <a:r>
-              <a:rPr lang="es-MX" baseline="0" dirty="0" err="1" smtClean="0"/>
-              <a:t>on</a:t>
-            </a:r>
-            <a:r>
-              <a:rPr lang="es-MX" baseline="0" dirty="0" smtClean="0"/>
-              <a:t> </a:t>
-            </a:r>
-            <a:r>
-              <a:rPr lang="es-MX" baseline="0" dirty="0" err="1" smtClean="0"/>
-              <a:t>others</a:t>
-            </a:r>
-            <a:r>
-              <a:rPr lang="es-MX" baseline="0" dirty="0" smtClean="0"/>
-              <a:t> (</a:t>
-            </a:r>
-            <a:r>
-              <a:rPr lang="es-MX" baseline="0" dirty="0" err="1" smtClean="0"/>
-              <a:t>Alchornea</a:t>
-            </a:r>
-            <a:r>
-              <a:rPr lang="es-MX" baseline="0" dirty="0" smtClean="0"/>
-              <a:t>, </a:t>
-            </a:r>
-            <a:r>
-              <a:rPr lang="es-MX" baseline="0" dirty="0" err="1" smtClean="0"/>
-              <a:t>Weinmania</a:t>
-            </a:r>
-            <a:r>
-              <a:rPr lang="es-MX" baseline="0" dirty="0" smtClean="0"/>
-              <a:t>).</a:t>
-            </a:r>
-          </a:p>
-          <a:p>
             <a:endParaRPr lang="en-US" dirty="0"/>
           </a:p>
         </p:txBody>
@@ -2548,173 +2151,7 @@
           <a:p>
             <a:fld id="{FB953BC2-43C1-4767-ADF3-5E906A4AA839}" type="slidenum">
               <a:rPr lang="en-US" smtClean="0"/>
-              <a:t>12</a:t>
-            </a:fld>
-            <a:endParaRPr lang="en-US"/>
-          </a:p>
-        </p:txBody>
-      </p:sp>
-    </p:spTree>
-    <p:extLst>
-      <p:ext uri="{BB962C8B-B14F-4D97-AF65-F5344CB8AC3E}">
-        <p14:creationId xmlns:p14="http://schemas.microsoft.com/office/powerpoint/2010/main" val="1108890781"/>
-      </p:ext>
-    </p:extLst>
-  </p:cSld>
-  <p:clrMapOvr>
-    <a:masterClrMapping/>
-  </p:clrMapOvr>
-</p:notes>
-</file>
-
-<file path=ppt/notesSlides/notesSlide7.xml><?xml version="1.0" encoding="utf-8"?>
-<p:notes xmlns:a="http://schemas.openxmlformats.org/drawingml/2006/main" xmlns:r="http://schemas.openxmlformats.org/officeDocument/2006/relationships" xmlns:p="http://schemas.openxmlformats.org/presentationml/2006/main">
-  <p:cSld>
-    <p:spTree>
-      <p:nvGrpSpPr>
-        <p:cNvPr id="1" name=""/>
-        <p:cNvGrpSpPr/>
-        <p:nvPr/>
-      </p:nvGrpSpPr>
-      <p:grpSpPr>
-        <a:xfrm>
-          <a:off x="0" y="0"/>
-          <a:ext cx="0" cy="0"/>
-          <a:chOff x="0" y="0"/>
-          <a:chExt cx="0" cy="0"/>
-        </a:xfrm>
-      </p:grpSpPr>
-      <p:sp>
-        <p:nvSpPr>
-          <p:cNvPr id="2" name="Marcador de imagen de diapositiva 1"/>
-          <p:cNvSpPr>
-            <a:spLocks noGrp="1" noRot="1" noChangeAspect="1"/>
-          </p:cNvSpPr>
-          <p:nvPr>
-            <p:ph type="sldImg"/>
-          </p:nvPr>
-        </p:nvSpPr>
-        <p:spPr/>
-      </p:sp>
-      <p:sp>
-        <p:nvSpPr>
-          <p:cNvPr id="3" name="Marcador de notas 2"/>
-          <p:cNvSpPr>
-            <a:spLocks noGrp="1"/>
-          </p:cNvSpPr>
-          <p:nvPr>
-            <p:ph type="body" idx="1"/>
-          </p:nvPr>
-        </p:nvSpPr>
-        <p:spPr/>
-        <p:txBody>
-          <a:bodyPr/>
-          <a:lstStyle/>
-          <a:p>
-            <a:r>
-              <a:rPr lang="es-MX" dirty="0" err="1" smtClean="0"/>
-              <a:t>None</a:t>
-            </a:r>
-            <a:r>
-              <a:rPr lang="es-MX" dirty="0" smtClean="0"/>
-              <a:t> of </a:t>
-            </a:r>
-            <a:r>
-              <a:rPr lang="es-MX" dirty="0" err="1" smtClean="0"/>
-              <a:t>them</a:t>
-            </a:r>
-            <a:r>
-              <a:rPr lang="es-MX" dirty="0" smtClean="0"/>
-              <a:t> are </a:t>
-            </a:r>
-            <a:r>
-              <a:rPr lang="es-MX" dirty="0" err="1" smtClean="0"/>
-              <a:t>nitrogen</a:t>
-            </a:r>
-            <a:r>
-              <a:rPr lang="es-MX" dirty="0" smtClean="0"/>
-              <a:t> </a:t>
-            </a:r>
-            <a:r>
-              <a:rPr lang="es-MX" dirty="0" err="1" smtClean="0"/>
-              <a:t>fixing</a:t>
-            </a:r>
-            <a:r>
-              <a:rPr lang="es-MX" dirty="0" smtClean="0"/>
-              <a:t> </a:t>
-            </a:r>
-            <a:r>
-              <a:rPr lang="es-MX" dirty="0" err="1" smtClean="0"/>
-              <a:t>species</a:t>
-            </a:r>
-            <a:r>
-              <a:rPr lang="es-MX" dirty="0" smtClean="0"/>
-              <a:t>.</a:t>
-            </a:r>
-          </a:p>
-          <a:p>
-            <a:r>
-              <a:rPr lang="es-MX" dirty="0" err="1" smtClean="0"/>
-              <a:t>How</a:t>
-            </a:r>
-            <a:r>
-              <a:rPr lang="es-MX" dirty="0" smtClean="0"/>
-              <a:t> to </a:t>
-            </a:r>
-            <a:r>
-              <a:rPr lang="es-MX" dirty="0" err="1" smtClean="0"/>
-              <a:t>interpret</a:t>
-            </a:r>
-            <a:r>
-              <a:rPr lang="es-MX" dirty="0" smtClean="0"/>
-              <a:t> </a:t>
-            </a:r>
-            <a:r>
-              <a:rPr lang="es-MX" dirty="0" err="1" smtClean="0"/>
-              <a:t>this</a:t>
-            </a:r>
-            <a:r>
-              <a:rPr lang="es-MX" dirty="0" smtClean="0"/>
-              <a:t> </a:t>
-            </a:r>
-            <a:r>
-              <a:rPr lang="es-MX" dirty="0" err="1" smtClean="0"/>
-              <a:t>one</a:t>
-            </a:r>
-            <a:r>
-              <a:rPr lang="es-MX" dirty="0" smtClean="0"/>
-              <a:t> </a:t>
-            </a:r>
-            <a:r>
-              <a:rPr lang="es-MX" dirty="0" err="1" smtClean="0"/>
-              <a:t>better</a:t>
-            </a:r>
-            <a:r>
-              <a:rPr lang="es-MX" dirty="0" smtClean="0"/>
-              <a:t>.</a:t>
-            </a:r>
-            <a:endParaRPr lang="en-US" dirty="0"/>
-          </a:p>
-        </p:txBody>
-      </p:sp>
-      <p:sp>
-        <p:nvSpPr>
-          <p:cNvPr id="4" name="Marcador de número de diapositiva 3"/>
-          <p:cNvSpPr>
-            <a:spLocks noGrp="1"/>
-          </p:cNvSpPr>
-          <p:nvPr>
-            <p:ph type="sldNum" sz="quarter" idx="10"/>
-          </p:nvPr>
-        </p:nvSpPr>
-        <p:spPr/>
-        <p:txBody>
-          <a:bodyPr/>
-          <a:lstStyle/>
-          <a:p>
-            <a:fld id="{FB953BC2-43C1-4767-ADF3-5E906A4AA839}" type="slidenum">
-              <a:rPr lang="en-US" smtClean="0"/>
-              <a:t>15</a:t>
+              <a:t>14</a:t>
             </a:fld>
             <a:endParaRPr lang="en-US"/>
           </a:p>
@@ -2733,7 +2170,7 @@
 </p:notes>
 </file>
 
-<file path=ppt/notesSlides/notesSlide8.xml><?xml version="1.0" encoding="utf-8"?>
+<file path=ppt/notesSlides/notesSlide7.xml><?xml version="1.0" encoding="utf-8"?>
 <p:notes xmlns:a="http://schemas.openxmlformats.org/drawingml/2006/main" xmlns:r="http://schemas.openxmlformats.org/officeDocument/2006/relationships" xmlns:p="http://schemas.openxmlformats.org/presentationml/2006/main">
   <p:cSld>
     <p:spTree>
@@ -2798,6 +2235,316 @@
           <a:p>
             <a:fld id="{FB953BC2-43C1-4767-ADF3-5E906A4AA839}" type="slidenum">
               <a:rPr lang="en-US" smtClean="0"/>
+              <a:t>15</a:t>
+            </a:fld>
+            <a:endParaRPr lang="en-US"/>
+          </a:p>
+        </p:txBody>
+      </p:sp>
+    </p:spTree>
+    <p:extLst>
+      <p:ext uri="{BB962C8B-B14F-4D97-AF65-F5344CB8AC3E}">
+        <p14:creationId xmlns:p14="http://schemas.microsoft.com/office/powerpoint/2010/main" val="1672766010"/>
+      </p:ext>
+    </p:extLst>
+  </p:cSld>
+  <p:clrMapOvr>
+    <a:masterClrMapping/>
+  </p:clrMapOvr>
+</p:notes>
+</file>
+
+<file path=ppt/notesSlides/notesSlide8.xml><?xml version="1.0" encoding="utf-8"?>
+<p:notes xmlns:a="http://schemas.openxmlformats.org/drawingml/2006/main" xmlns:r="http://schemas.openxmlformats.org/officeDocument/2006/relationships" xmlns:p="http://schemas.openxmlformats.org/presentationml/2006/main">
+  <p:cSld>
+    <p:spTree>
+      <p:nvGrpSpPr>
+        <p:cNvPr id="1" name=""/>
+        <p:cNvGrpSpPr/>
+        <p:nvPr/>
+      </p:nvGrpSpPr>
+      <p:grpSpPr>
+        <a:xfrm>
+          <a:off x="0" y="0"/>
+          <a:ext cx="0" cy="0"/>
+          <a:chOff x="0" y="0"/>
+          <a:chExt cx="0" cy="0"/>
+        </a:xfrm>
+      </p:grpSpPr>
+      <p:sp>
+        <p:nvSpPr>
+          <p:cNvPr id="2" name="Marcador de imagen de diapositiva 1"/>
+          <p:cNvSpPr>
+            <a:spLocks noGrp="1" noRot="1" noChangeAspect="1"/>
+          </p:cNvSpPr>
+          <p:nvPr>
+            <p:ph type="sldImg"/>
+          </p:nvPr>
+        </p:nvSpPr>
+        <p:spPr/>
+      </p:sp>
+      <p:sp>
+        <p:nvSpPr>
+          <p:cNvPr id="3" name="Marcador de notas 2"/>
+          <p:cNvSpPr>
+            <a:spLocks noGrp="1"/>
+          </p:cNvSpPr>
+          <p:nvPr>
+            <p:ph type="body" idx="1"/>
+          </p:nvPr>
+        </p:nvSpPr>
+        <p:spPr/>
+        <p:txBody>
+          <a:bodyPr/>
+          <a:lstStyle/>
+          <a:p>
+            <a:r>
+              <a:rPr lang="es-MX" dirty="0" err="1" smtClean="0"/>
+              <a:t>Pouteria</a:t>
+            </a:r>
+            <a:r>
+              <a:rPr lang="es-MX" dirty="0" smtClean="0"/>
+              <a:t> torta, </a:t>
+            </a:r>
+            <a:r>
+              <a:rPr lang="es-MX" dirty="0" err="1" smtClean="0"/>
+              <a:t>effect</a:t>
+            </a:r>
+            <a:r>
+              <a:rPr lang="es-MX" dirty="0" smtClean="0"/>
+              <a:t> of </a:t>
+            </a:r>
+            <a:r>
+              <a:rPr lang="es-MX" dirty="0" err="1" smtClean="0"/>
+              <a:t>the</a:t>
+            </a:r>
+            <a:r>
+              <a:rPr lang="es-MX" dirty="0" smtClean="0"/>
+              <a:t> N</a:t>
+            </a:r>
+            <a:r>
+              <a:rPr lang="es-MX" baseline="0" dirty="0" smtClean="0"/>
+              <a:t> and N*P </a:t>
+            </a:r>
+            <a:r>
+              <a:rPr lang="es-MX" baseline="0" dirty="0" err="1" smtClean="0"/>
+              <a:t>on</a:t>
+            </a:r>
+            <a:r>
+              <a:rPr lang="es-MX" baseline="0" dirty="0" smtClean="0"/>
+              <a:t> </a:t>
+            </a:r>
+            <a:r>
+              <a:rPr lang="es-MX" baseline="0" dirty="0" err="1" smtClean="0"/>
+              <a:t>iWUE</a:t>
+            </a:r>
+            <a:r>
+              <a:rPr lang="es-MX" baseline="0" dirty="0" smtClean="0"/>
+              <a:t>, and </a:t>
+            </a:r>
+            <a:r>
+              <a:rPr lang="es-MX" baseline="0" dirty="0" err="1" smtClean="0"/>
+              <a:t>effect</a:t>
+            </a:r>
+            <a:r>
+              <a:rPr lang="es-MX" baseline="0" dirty="0" smtClean="0"/>
+              <a:t> of P o d18O. </a:t>
+            </a:r>
+            <a:r>
+              <a:rPr lang="es-MX" baseline="0" dirty="0" err="1" smtClean="0"/>
+              <a:t>This</a:t>
+            </a:r>
+            <a:r>
+              <a:rPr lang="es-MX" baseline="0" dirty="0" smtClean="0"/>
+              <a:t> </a:t>
+            </a:r>
+            <a:r>
+              <a:rPr lang="es-MX" baseline="0" dirty="0" err="1" smtClean="0"/>
+              <a:t>is</a:t>
+            </a:r>
+            <a:r>
+              <a:rPr lang="es-MX" baseline="0" dirty="0" smtClean="0"/>
+              <a:t> </a:t>
+            </a:r>
+            <a:r>
+              <a:rPr lang="es-MX" baseline="0" dirty="0" err="1" smtClean="0"/>
+              <a:t>the</a:t>
+            </a:r>
+            <a:r>
+              <a:rPr lang="es-MX" baseline="0" dirty="0" smtClean="0"/>
+              <a:t> </a:t>
+            </a:r>
+            <a:r>
+              <a:rPr lang="es-MX" baseline="0" dirty="0" err="1" smtClean="0"/>
+              <a:t>only</a:t>
+            </a:r>
+            <a:r>
+              <a:rPr lang="es-MX" baseline="0" dirty="0" smtClean="0"/>
+              <a:t> </a:t>
+            </a:r>
+            <a:r>
+              <a:rPr lang="es-MX" baseline="0" dirty="0" err="1" smtClean="0"/>
+              <a:t>specie</a:t>
+            </a:r>
+            <a:r>
+              <a:rPr lang="es-MX" baseline="0" dirty="0" smtClean="0"/>
+              <a:t> </a:t>
+            </a:r>
+            <a:r>
+              <a:rPr lang="es-MX" baseline="0" dirty="0" err="1" smtClean="0"/>
+              <a:t>giving</a:t>
+            </a:r>
+            <a:r>
+              <a:rPr lang="es-MX" baseline="0" dirty="0" smtClean="0"/>
+              <a:t> a </a:t>
+            </a:r>
+            <a:r>
+              <a:rPr lang="es-MX" baseline="0" dirty="0" err="1" smtClean="0"/>
+              <a:t>statistical</a:t>
+            </a:r>
+            <a:r>
+              <a:rPr lang="es-MX" baseline="0" dirty="0" smtClean="0"/>
+              <a:t> </a:t>
+            </a:r>
+            <a:r>
+              <a:rPr lang="es-MX" baseline="0" dirty="0" err="1" smtClean="0"/>
+              <a:t>signal</a:t>
+            </a:r>
+            <a:r>
+              <a:rPr lang="es-MX" baseline="0" dirty="0" smtClean="0"/>
+              <a:t> response to </a:t>
+            </a:r>
+            <a:r>
+              <a:rPr lang="es-MX" baseline="0" dirty="0" err="1" smtClean="0"/>
+              <a:t>nutrient</a:t>
+            </a:r>
+            <a:r>
+              <a:rPr lang="es-MX" baseline="0" dirty="0" smtClean="0"/>
+              <a:t> </a:t>
+            </a:r>
+            <a:r>
+              <a:rPr lang="es-MX" baseline="0" dirty="0" err="1" smtClean="0"/>
+              <a:t>addition</a:t>
+            </a:r>
+            <a:r>
+              <a:rPr lang="es-MX" baseline="0" dirty="0" smtClean="0"/>
+              <a:t> </a:t>
+            </a:r>
+            <a:r>
+              <a:rPr lang="es-MX" baseline="0" dirty="0" err="1" smtClean="0"/>
+              <a:t>on</a:t>
+            </a:r>
+            <a:r>
+              <a:rPr lang="es-MX" baseline="0" dirty="0" smtClean="0"/>
+              <a:t> </a:t>
+            </a:r>
+            <a:r>
+              <a:rPr lang="es-MX" baseline="0" dirty="0" err="1" smtClean="0"/>
+              <a:t>iQUE</a:t>
+            </a:r>
+            <a:r>
+              <a:rPr lang="es-MX" baseline="0" dirty="0" smtClean="0"/>
+              <a:t>.</a:t>
+            </a:r>
+          </a:p>
+          <a:p>
+            <a:r>
+              <a:rPr lang="es-MX" baseline="0" dirty="0" err="1" smtClean="0"/>
+              <a:t>Alchornea</a:t>
+            </a:r>
+            <a:r>
+              <a:rPr lang="es-MX" baseline="0" dirty="0" smtClean="0"/>
+              <a:t>, </a:t>
+            </a:r>
+            <a:r>
+              <a:rPr lang="es-MX" baseline="0" dirty="0" err="1" smtClean="0"/>
+              <a:t>effect</a:t>
+            </a:r>
+            <a:r>
+              <a:rPr lang="es-MX" baseline="0" dirty="0" smtClean="0"/>
+              <a:t> of </a:t>
+            </a:r>
+            <a:r>
+              <a:rPr lang="es-MX" baseline="0" dirty="0" err="1" smtClean="0"/>
+              <a:t>the</a:t>
+            </a:r>
+            <a:r>
+              <a:rPr lang="es-MX" baseline="0" dirty="0" smtClean="0"/>
+              <a:t> N </a:t>
+            </a:r>
+            <a:r>
+              <a:rPr lang="es-MX" baseline="0" dirty="0" err="1" smtClean="0"/>
+              <a:t>on</a:t>
+            </a:r>
+            <a:r>
+              <a:rPr lang="es-MX" baseline="0" dirty="0" smtClean="0"/>
+              <a:t> d15N and C:N. </a:t>
+            </a:r>
+          </a:p>
+          <a:p>
+            <a:r>
+              <a:rPr lang="es-MX" baseline="0" dirty="0" err="1" smtClean="0"/>
+              <a:t>Myrcia</a:t>
+            </a:r>
+            <a:r>
+              <a:rPr lang="es-MX" baseline="0" dirty="0" smtClean="0"/>
+              <a:t>, </a:t>
+            </a:r>
+            <a:r>
+              <a:rPr lang="es-MX" baseline="0" dirty="0" err="1" smtClean="0"/>
+              <a:t>effect</a:t>
+            </a:r>
+            <a:r>
+              <a:rPr lang="es-MX" baseline="0" dirty="0" smtClean="0"/>
+              <a:t> of N </a:t>
+            </a:r>
+            <a:r>
+              <a:rPr lang="es-MX" baseline="0" dirty="0" err="1" smtClean="0"/>
+              <a:t>on</a:t>
+            </a:r>
+            <a:r>
+              <a:rPr lang="es-MX" baseline="0" dirty="0" smtClean="0"/>
+              <a:t> d18O, d15N, C:N</a:t>
+            </a:r>
+          </a:p>
+          <a:p>
+            <a:r>
+              <a:rPr lang="es-MX" baseline="0" dirty="0" err="1" smtClean="0"/>
+              <a:t>Hedyosmum</a:t>
+            </a:r>
+            <a:r>
+              <a:rPr lang="es-MX" baseline="0" dirty="0" smtClean="0"/>
+              <a:t>, </a:t>
+            </a:r>
+            <a:r>
+              <a:rPr lang="es-MX" baseline="0" dirty="0" err="1" smtClean="0"/>
+              <a:t>effect</a:t>
+            </a:r>
+            <a:r>
+              <a:rPr lang="es-MX" baseline="0" dirty="0" smtClean="0"/>
+              <a:t> of d15N and C:N. (+ p &lt;0.1)</a:t>
+            </a:r>
+            <a:endParaRPr lang="en-US" dirty="0"/>
+          </a:p>
+        </p:txBody>
+      </p:sp>
+      <p:sp>
+        <p:nvSpPr>
+          <p:cNvPr id="4" name="Marcador de número de diapositiva 3"/>
+          <p:cNvSpPr>
+            <a:spLocks noGrp="1"/>
+          </p:cNvSpPr>
+          <p:nvPr>
+            <p:ph type="sldNum" sz="quarter" idx="10"/>
+          </p:nvPr>
+        </p:nvSpPr>
+        <p:spPr/>
+        <p:txBody>
+          <a:bodyPr/>
+          <a:lstStyle/>
+          <a:p>
+            <a:fld id="{FB953BC2-43C1-4767-ADF3-5E906A4AA839}" type="slidenum">
+              <a:rPr lang="en-US" smtClean="0"/>
               <a:t>16</a:t>
             </a:fld>
             <a:endParaRPr lang="en-US"/>
@@ -2807,7 +2554,7 @@
     </p:spTree>
     <p:extLst>
       <p:ext uri="{BB962C8B-B14F-4D97-AF65-F5344CB8AC3E}">
-        <p14:creationId xmlns:p14="http://schemas.microsoft.com/office/powerpoint/2010/main" val="1672766010"/>
+        <p14:creationId xmlns:p14="http://schemas.microsoft.com/office/powerpoint/2010/main" val="3466854139"/>
       </p:ext>
     </p:extLst>
   </p:cSld>
@@ -2862,230 +2609,16 @@
           <a:lstStyle/>
           <a:p>
             <a:r>
+              <a:rPr lang="es-MX" dirty="0" smtClean="0"/>
+              <a:t>U </a:t>
+            </a:r>
+            <a:r>
               <a:rPr lang="es-MX" dirty="0" err="1" smtClean="0"/>
-              <a:t>Pouteria</a:t>
+              <a:t>shaped</a:t>
             </a:r>
             <a:r>
               <a:rPr lang="es-MX" dirty="0" smtClean="0"/>
-              <a:t> torta, </a:t>
-            </a:r>
-            <a:r>
-              <a:rPr lang="es-MX" dirty="0" err="1" smtClean="0"/>
-              <a:t>effect</a:t>
-            </a:r>
-            <a:r>
-              <a:rPr lang="es-MX" dirty="0" smtClean="0"/>
-              <a:t> of </a:t>
-            </a:r>
-            <a:r>
-              <a:rPr lang="es-MX" dirty="0" err="1" smtClean="0"/>
-              <a:t>the</a:t>
-            </a:r>
-            <a:r>
-              <a:rPr lang="es-MX" dirty="0" smtClean="0"/>
-              <a:t> N</a:t>
-            </a:r>
-            <a:r>
-              <a:rPr lang="es-MX" baseline="0" dirty="0" smtClean="0"/>
-              <a:t> and N*P </a:t>
-            </a:r>
-            <a:r>
-              <a:rPr lang="es-MX" baseline="0" dirty="0" err="1" smtClean="0"/>
-              <a:t>on</a:t>
-            </a:r>
-            <a:r>
-              <a:rPr lang="es-MX" baseline="0" dirty="0" smtClean="0"/>
-              <a:t> </a:t>
-            </a:r>
-            <a:r>
-              <a:rPr lang="es-MX" baseline="0" dirty="0" err="1" smtClean="0"/>
-              <a:t>iWUE</a:t>
-            </a:r>
-            <a:r>
-              <a:rPr lang="es-MX" baseline="0" dirty="0" smtClean="0"/>
-              <a:t>, and </a:t>
-            </a:r>
-            <a:r>
-              <a:rPr lang="es-MX" baseline="0" dirty="0" err="1" smtClean="0"/>
-              <a:t>effect</a:t>
-            </a:r>
-            <a:r>
-              <a:rPr lang="es-MX" baseline="0" dirty="0" smtClean="0"/>
-              <a:t> of P o d18O. </a:t>
-            </a:r>
-            <a:r>
-              <a:rPr lang="es-MX" baseline="0" dirty="0" err="1" smtClean="0"/>
-              <a:t>This</a:t>
-            </a:r>
-            <a:r>
-              <a:rPr lang="es-MX" baseline="0" dirty="0" smtClean="0"/>
-              <a:t> </a:t>
-            </a:r>
-            <a:r>
-              <a:rPr lang="es-MX" baseline="0" dirty="0" err="1" smtClean="0"/>
-              <a:t>is</a:t>
-            </a:r>
-            <a:r>
-              <a:rPr lang="es-MX" baseline="0" dirty="0" smtClean="0"/>
-              <a:t> </a:t>
-            </a:r>
-            <a:r>
-              <a:rPr lang="es-MX" baseline="0" dirty="0" err="1" smtClean="0"/>
-              <a:t>the</a:t>
-            </a:r>
-            <a:r>
-              <a:rPr lang="es-MX" baseline="0" dirty="0" smtClean="0"/>
-              <a:t> </a:t>
-            </a:r>
-            <a:r>
-              <a:rPr lang="es-MX" baseline="0" dirty="0" err="1" smtClean="0"/>
-              <a:t>only</a:t>
-            </a:r>
-            <a:r>
-              <a:rPr lang="es-MX" baseline="0" dirty="0" smtClean="0"/>
-              <a:t> </a:t>
-            </a:r>
-            <a:r>
-              <a:rPr lang="es-MX" baseline="0" dirty="0" err="1" smtClean="0"/>
-              <a:t>specie</a:t>
-            </a:r>
-            <a:r>
-              <a:rPr lang="es-MX" baseline="0" dirty="0" smtClean="0"/>
-              <a:t> </a:t>
-            </a:r>
-            <a:r>
-              <a:rPr lang="es-MX" baseline="0" dirty="0" err="1" smtClean="0"/>
-              <a:t>giving</a:t>
-            </a:r>
-            <a:r>
-              <a:rPr lang="es-MX" baseline="0" dirty="0" smtClean="0"/>
-              <a:t> a </a:t>
-            </a:r>
-            <a:r>
-              <a:rPr lang="es-MX" baseline="0" dirty="0" err="1" smtClean="0"/>
-              <a:t>statistical</a:t>
-            </a:r>
-            <a:r>
-              <a:rPr lang="es-MX" baseline="0" dirty="0" smtClean="0"/>
-              <a:t> </a:t>
-            </a:r>
-            <a:r>
-              <a:rPr lang="es-MX" baseline="0" dirty="0" err="1" smtClean="0"/>
-              <a:t>signal</a:t>
-            </a:r>
-            <a:r>
-              <a:rPr lang="es-MX" baseline="0" dirty="0" smtClean="0"/>
-              <a:t> response to </a:t>
-            </a:r>
-            <a:r>
-              <a:rPr lang="es-MX" baseline="0" dirty="0" err="1" smtClean="0"/>
-              <a:t>nutrient</a:t>
-            </a:r>
-            <a:r>
-              <a:rPr lang="es-MX" baseline="0" dirty="0" smtClean="0"/>
-              <a:t> </a:t>
-            </a:r>
-            <a:r>
-              <a:rPr lang="es-MX" baseline="0" dirty="0" err="1" smtClean="0"/>
-              <a:t>addition</a:t>
-            </a:r>
-            <a:r>
-              <a:rPr lang="es-MX" baseline="0" dirty="0" smtClean="0"/>
-              <a:t> </a:t>
-            </a:r>
-            <a:r>
-              <a:rPr lang="es-MX" baseline="0" dirty="0" err="1" smtClean="0"/>
-              <a:t>on</a:t>
-            </a:r>
-            <a:r>
-              <a:rPr lang="es-MX" baseline="0" dirty="0" smtClean="0"/>
-              <a:t> </a:t>
-            </a:r>
-            <a:r>
-              <a:rPr lang="es-MX" baseline="0" dirty="0" err="1" smtClean="0"/>
-              <a:t>iQUE</a:t>
-            </a:r>
-            <a:r>
-              <a:rPr lang="es-MX" baseline="0" dirty="0" smtClean="0"/>
               <a:t>.</a:t>
-            </a:r>
-          </a:p>
-          <a:p>
-            <a:r>
-              <a:rPr lang="es-MX" baseline="0" dirty="0" err="1" smtClean="0"/>
-              <a:t>Alchornea</a:t>
-            </a:r>
-            <a:r>
-              <a:rPr lang="es-MX" baseline="0" dirty="0" smtClean="0"/>
-              <a:t>, </a:t>
-            </a:r>
-            <a:r>
-              <a:rPr lang="es-MX" baseline="0" dirty="0" err="1" smtClean="0"/>
-              <a:t>effect</a:t>
-            </a:r>
-            <a:r>
-              <a:rPr lang="es-MX" baseline="0" dirty="0" smtClean="0"/>
-              <a:t> of </a:t>
-            </a:r>
-            <a:r>
-              <a:rPr lang="es-MX" baseline="0" dirty="0" err="1" smtClean="0"/>
-              <a:t>the</a:t>
-            </a:r>
-            <a:r>
-              <a:rPr lang="es-MX" baseline="0" dirty="0" smtClean="0"/>
-              <a:t> N </a:t>
-            </a:r>
-            <a:r>
-              <a:rPr lang="es-MX" baseline="0" dirty="0" err="1" smtClean="0"/>
-              <a:t>on</a:t>
-            </a:r>
-            <a:r>
-              <a:rPr lang="es-MX" baseline="0" dirty="0" smtClean="0"/>
-              <a:t> d15N and C:N. </a:t>
-            </a:r>
-          </a:p>
-          <a:p>
-            <a:r>
-              <a:rPr lang="es-MX" baseline="0" dirty="0" err="1" smtClean="0"/>
-              <a:t>Myrcia</a:t>
-            </a:r>
-            <a:r>
-              <a:rPr lang="es-MX" baseline="0" dirty="0" smtClean="0"/>
-              <a:t>, </a:t>
-            </a:r>
-            <a:r>
-              <a:rPr lang="es-MX" baseline="0" dirty="0" err="1" smtClean="0"/>
-              <a:t>effect</a:t>
-            </a:r>
-            <a:r>
-              <a:rPr lang="es-MX" baseline="0" dirty="0" smtClean="0"/>
-              <a:t> of N </a:t>
-            </a:r>
-            <a:r>
-              <a:rPr lang="es-MX" baseline="0" dirty="0" err="1" smtClean="0"/>
-              <a:t>on</a:t>
-            </a:r>
-            <a:r>
-              <a:rPr lang="es-MX" baseline="0" dirty="0" smtClean="0"/>
-              <a:t> d18O, d15N, C:N</a:t>
-            </a:r>
-          </a:p>
-          <a:p>
-            <a:r>
-              <a:rPr lang="es-MX" baseline="0" dirty="0" err="1" smtClean="0"/>
-              <a:t>Hedyosmum</a:t>
-            </a:r>
-            <a:r>
-              <a:rPr lang="es-MX" baseline="0" dirty="0" smtClean="0"/>
-              <a:t>, </a:t>
-            </a:r>
-            <a:r>
-              <a:rPr lang="es-MX" baseline="0" dirty="0" err="1" smtClean="0"/>
-              <a:t>effect</a:t>
-            </a:r>
-            <a:r>
-              <a:rPr lang="es-MX" baseline="0" dirty="0" smtClean="0"/>
-              <a:t> of d15N and C:N. (+ p &lt;0.1)</a:t>
             </a:r>
             <a:endParaRPr lang="en-US" dirty="0"/>
           </a:p>
@@ -3108,7 +2641,7 @@
           <a:p>
             <a:fld id="{FB953BC2-43C1-4767-ADF3-5E906A4AA839}" type="slidenum">
               <a:rPr lang="en-US" smtClean="0"/>
-              <a:t>17</a:t>
+              <a:t>18</a:t>
             </a:fld>
             <a:endParaRPr lang="en-US"/>
           </a:p>
@@ -3117,7 +2650,7 @@
     </p:spTree>
     <p:extLst>
       <p:ext uri="{BB962C8B-B14F-4D97-AF65-F5344CB8AC3E}">
-        <p14:creationId xmlns:p14="http://schemas.microsoft.com/office/powerpoint/2010/main" val="3466854139"/>
+        <p14:creationId xmlns:p14="http://schemas.microsoft.com/office/powerpoint/2010/main" val="2152417619"/>
       </p:ext>
     </p:extLst>
   </p:cSld>
@@ -6445,55 +5978,29 @@
       </p:grpSpPr>
       <p:sp>
         <p:nvSpPr>
-          <p:cNvPr id="5" name="Rectángulo 4"/>
-          <p:cNvSpPr/>
+          <p:cNvPr id="24" name="CuadroTexto 23"/>
+          <p:cNvSpPr txBox="1"/>
           <p:nvPr/>
         </p:nvSpPr>
         <p:spPr>
           <a:xfrm>
-            <a:off x="667512" y="164030"/>
-            <a:ext cx="1691640" cy="402898"/>
+            <a:off x="534039" y="997973"/>
+            <a:ext cx="274320" cy="369332"/>
           </a:xfrm>
           <a:prstGeom prst="rect">
             <a:avLst/>
           </a:prstGeom>
+          <a:noFill/>
         </p:spPr>
-        <p:style>
-          <a:lnRef idx="2">
-            <a:schemeClr val="accent1">
-              <a:shade val="50000"/>
-            </a:schemeClr>
-          </a:lnRef>
-          <a:fillRef idx="1">
-            <a:schemeClr val="accent1"/>
-          </a:fillRef>
-          <a:effectRef idx="0">
-            <a:schemeClr val="accent1"/>
-          </a:effectRef>
-          <a:fontRef idx="minor">
-            <a:schemeClr val="lt1"/>
-          </a:fontRef>
-        </p:style>
         <p:txBody>
-          <a:bodyPr rtlCol="0" anchor="ctr"/>
+          <a:bodyPr wrap="square" rtlCol="0">
+            <a:spAutoFit/>
+          </a:bodyPr>
           <a:lstStyle/>
           <a:p>
-            <a:pPr algn="ctr"/>
             <a:r>
               <a:rPr lang="es-MX" dirty="0" smtClean="0"/>
               <a:t>*</a:t>
-            </a:r>
-            <a:r>
-              <a:rPr lang="es-MX" dirty="0" err="1" smtClean="0"/>
-              <a:t>Missing</a:t>
-            </a:r>
-            <a:r>
-              <a:rPr lang="es-MX" dirty="0" smtClean="0"/>
-              <a:t> </a:t>
-            </a:r>
-            <a:r>
-              <a:rPr lang="es-MX" dirty="0" err="1" smtClean="0"/>
-              <a:t>values</a:t>
             </a:r>
             <a:endParaRPr lang="en-US" dirty="0"/>
           </a:p>
@@ -6501,7 +6008,7 @@
       </p:sp>
       <p:pic>
         <p:nvPicPr>
-          <p:cNvPr id="17" name="Imagen 16"/>
+          <p:cNvPr id="2" name="Imagen 1"/>
           <p:cNvPicPr>
             <a:picLocks noChangeAspect="1"/>
           </p:cNvPicPr>
@@ -6515,32 +6022,8 @@
         </p:blipFill>
         <p:spPr>
           <a:xfrm>
-            <a:off x="327089" y="1108708"/>
-            <a:ext cx="5662232" cy="4640584"/>
-          </a:xfrm>
-          <a:prstGeom prst="rect">
-            <a:avLst/>
-          </a:prstGeom>
-        </p:spPr>
-      </p:pic>
-      <p:pic>
-        <p:nvPicPr>
-          <p:cNvPr id="21" name="Imagen 20"/>
-          <p:cNvPicPr>
-            <a:picLocks noChangeAspect="1"/>
-          </p:cNvPicPr>
-          <p:nvPr/>
-        </p:nvPicPr>
-        <p:blipFill>
-          <a:blip r:embed="rId4"/>
-          <a:stretch>
-            <a:fillRect/>
-          </a:stretch>
-        </p:blipFill>
-        <p:spPr>
-          <a:xfrm>
-            <a:off x="6096000" y="1200148"/>
-            <a:ext cx="5680746" cy="4661681"/>
+            <a:off x="945519" y="179201"/>
+            <a:ext cx="7918262" cy="6497810"/>
           </a:xfrm>
           <a:prstGeom prst="rect">
             <a:avLst/>
@@ -6549,103 +6032,13 @@
       </p:pic>
       <p:sp>
         <p:nvSpPr>
-          <p:cNvPr id="22" name="CuadroTexto 21"/>
-          <p:cNvSpPr txBox="1"/>
-          <p:nvPr/>
-        </p:nvSpPr>
-        <p:spPr>
-          <a:xfrm>
-            <a:off x="1068801" y="3793116"/>
-            <a:ext cx="274320" cy="369332"/>
-          </a:xfrm>
-          <a:prstGeom prst="rect">
-            <a:avLst/>
-          </a:prstGeom>
-          <a:noFill/>
-        </p:spPr>
-        <p:txBody>
-          <a:bodyPr wrap="square" rtlCol="0">
-            <a:spAutoFit/>
-          </a:bodyPr>
-          <a:lstStyle/>
-          <a:p>
-            <a:r>
-              <a:rPr lang="es-MX" dirty="0" smtClean="0"/>
-              <a:t>*</a:t>
-            </a:r>
-            <a:endParaRPr lang="en-US" dirty="0"/>
-          </a:p>
-        </p:txBody>
-      </p:sp>
-      <p:sp>
-        <p:nvSpPr>
-          <p:cNvPr id="23" name="CuadroTexto 22"/>
-          <p:cNvSpPr txBox="1"/>
-          <p:nvPr/>
-        </p:nvSpPr>
-        <p:spPr>
-          <a:xfrm>
-            <a:off x="2359152" y="3793116"/>
-            <a:ext cx="274320" cy="369332"/>
-          </a:xfrm>
-          <a:prstGeom prst="rect">
-            <a:avLst/>
-          </a:prstGeom>
-          <a:noFill/>
-        </p:spPr>
-        <p:txBody>
-          <a:bodyPr wrap="square" rtlCol="0">
-            <a:spAutoFit/>
-          </a:bodyPr>
-          <a:lstStyle/>
-          <a:p>
-            <a:r>
-              <a:rPr lang="es-MX" dirty="0" smtClean="0"/>
-              <a:t>*</a:t>
-            </a:r>
-            <a:endParaRPr lang="en-US" dirty="0"/>
-          </a:p>
-        </p:txBody>
-      </p:sp>
-      <p:sp>
-        <p:nvSpPr>
-          <p:cNvPr id="24" name="CuadroTexto 23"/>
-          <p:cNvSpPr txBox="1"/>
-          <p:nvPr/>
-        </p:nvSpPr>
-        <p:spPr>
-          <a:xfrm>
-            <a:off x="7641336" y="3977782"/>
-            <a:ext cx="274320" cy="369332"/>
-          </a:xfrm>
-          <a:prstGeom prst="rect">
-            <a:avLst/>
-          </a:prstGeom>
-          <a:noFill/>
-        </p:spPr>
-        <p:txBody>
-          <a:bodyPr wrap="square" rtlCol="0">
-            <a:spAutoFit/>
-          </a:bodyPr>
-          <a:lstStyle/>
-          <a:p>
-            <a:r>
-              <a:rPr lang="es-MX" dirty="0" smtClean="0"/>
-              <a:t>*</a:t>
-            </a:r>
-            <a:endParaRPr lang="en-US" dirty="0"/>
-          </a:p>
-        </p:txBody>
-      </p:sp>
-      <p:sp>
-        <p:nvSpPr>
           <p:cNvPr id="25" name="CuadroTexto 24"/>
           <p:cNvSpPr txBox="1"/>
           <p:nvPr/>
         </p:nvSpPr>
         <p:spPr>
           <a:xfrm>
-            <a:off x="8936373" y="1688734"/>
+            <a:off x="396879" y="628641"/>
             <a:ext cx="274320" cy="369332"/>
           </a:xfrm>
           <a:prstGeom prst="rect">
@@ -6689,150 +6082,6 @@
 
 <file path=ppt/slides/slide12.xml><?xml version="1.0" encoding="utf-8"?>
 <p:sld xmlns:a="http://schemas.openxmlformats.org/drawingml/2006/main" xmlns:r="http://schemas.openxmlformats.org/officeDocument/2006/relationships" xmlns:p="http://schemas.openxmlformats.org/presentationml/2006/main" show="0">
-  <p:cSld>
-    <p:spTree>
-      <p:nvGrpSpPr>
-        <p:cNvPr id="1" name=""/>
-        <p:cNvGrpSpPr/>
-        <p:nvPr/>
-      </p:nvGrpSpPr>
-      <p:grpSpPr>
-        <a:xfrm>
-          <a:off x="0" y="0"/>
-          <a:ext cx="0" cy="0"/>
-          <a:chOff x="0" y="0"/>
-          <a:chExt cx="0" cy="0"/>
-        </a:xfrm>
-      </p:grpSpPr>
-      <p:sp>
-        <p:nvSpPr>
-          <p:cNvPr id="5" name="Rectángulo 4"/>
-          <p:cNvSpPr/>
-          <p:nvPr/>
-        </p:nvSpPr>
-        <p:spPr>
-          <a:xfrm>
-            <a:off x="667512" y="164030"/>
-            <a:ext cx="1691640" cy="402898"/>
-          </a:xfrm>
-          <a:prstGeom prst="rect">
-            <a:avLst/>
-          </a:prstGeom>
-        </p:spPr>
-        <p:style>
-          <a:lnRef idx="2">
-            <a:schemeClr val="accent1">
-              <a:shade val="50000"/>
-            </a:schemeClr>
-          </a:lnRef>
-          <a:fillRef idx="1">
-            <a:schemeClr val="accent1"/>
-          </a:fillRef>
-          <a:effectRef idx="0">
-            <a:schemeClr val="accent1"/>
-          </a:effectRef>
-          <a:fontRef idx="minor">
-            <a:schemeClr val="lt1"/>
-          </a:fontRef>
-        </p:style>
-        <p:txBody>
-          <a:bodyPr rtlCol="0" anchor="ctr"/>
-          <a:lstStyle/>
-          <a:p>
-            <a:pPr algn="ctr"/>
-            <a:endParaRPr lang="en-US"/>
-          </a:p>
-        </p:txBody>
-      </p:sp>
-      <p:pic>
-        <p:nvPicPr>
-          <p:cNvPr id="18" name="Imagen 17"/>
-          <p:cNvPicPr>
-            <a:picLocks noChangeAspect="1"/>
-          </p:cNvPicPr>
-          <p:nvPr/>
-        </p:nvPicPr>
-        <p:blipFill>
-          <a:blip r:embed="rId3"/>
-          <a:stretch>
-            <a:fillRect/>
-          </a:stretch>
-        </p:blipFill>
-        <p:spPr>
-          <a:xfrm>
-            <a:off x="6096000" y="967552"/>
-            <a:ext cx="5834464" cy="4781740"/>
-          </a:xfrm>
-          <a:prstGeom prst="rect">
-            <a:avLst/>
-          </a:prstGeom>
-        </p:spPr>
-      </p:pic>
-      <p:cxnSp>
-        <p:nvCxnSpPr>
-          <p:cNvPr id="20" name="Conector recto 19"/>
-          <p:cNvCxnSpPr/>
-          <p:nvPr/>
-        </p:nvCxnSpPr>
-        <p:spPr>
-          <a:xfrm flipV="1">
-            <a:off x="7104888" y="566928"/>
-            <a:ext cx="4507992" cy="5779008"/>
-          </a:xfrm>
-          <a:prstGeom prst="line">
-            <a:avLst/>
-          </a:prstGeom>
-          <a:ln>
-            <a:solidFill>
-              <a:srgbClr val="FF0000"/>
-            </a:solidFill>
-          </a:ln>
-        </p:spPr>
-        <p:style>
-          <a:lnRef idx="3">
-            <a:schemeClr val="accent2"/>
-          </a:lnRef>
-          <a:fillRef idx="0">
-            <a:schemeClr val="accent2"/>
-          </a:fillRef>
-          <a:effectRef idx="2">
-            <a:schemeClr val="accent2"/>
-          </a:effectRef>
-          <a:fontRef idx="minor">
-            <a:schemeClr val="tx1"/>
-          </a:fontRef>
-        </p:style>
-      </p:cxnSp>
-    </p:spTree>
-    <p:extLst>
-      <p:ext uri="{BB962C8B-B14F-4D97-AF65-F5344CB8AC3E}">
-        <p14:creationId xmlns:p14="http://schemas.microsoft.com/office/powerpoint/2010/main" val="3118574709"/>
-      </p:ext>
-    </p:extLst>
-  </p:cSld>
-  <p:clrMapOvr>
-    <a:masterClrMapping/>
-  </p:clrMapOvr>
-  <mc:AlternateContent xmlns:mc="http://schemas.openxmlformats.org/markup-compatibility/2006" xmlns:p14="http://schemas.microsoft.com/office/powerpoint/2010/main">
-    <mc:Choice Requires="p14">
-      <p:transition spd="slow" p14:dur="2000"/>
-    </mc:Choice>
-    <mc:Fallback xmlns="">
-      <p:transition spd="slow"/>
-    </mc:Fallback>
-  </mc:AlternateContent>
-  <p:timing>
-    <p:tnLst>
-      <p:par>
-        <p:cTn id="1" dur="indefinite" restart="never" nodeType="tmRoot"/>
-      </p:par>
-    </p:tnLst>
-  </p:timing>
-</p:sld>
-</file>
-
-<file path=ppt/slides/slide13.xml><?xml version="1.0" encoding="utf-8"?>
-<p:sld xmlns:a="http://schemas.openxmlformats.org/drawingml/2006/main" xmlns:r="http://schemas.openxmlformats.org/officeDocument/2006/relationships" xmlns:p="http://schemas.openxmlformats.org/presentationml/2006/main">
   <p:cSld>
     <p:spTree>
       <p:nvGrpSpPr>
@@ -12031,6 +11280,14 @@
   <p:clrMapOvr>
     <a:masterClrMapping/>
   </p:clrMapOvr>
+  <mc:AlternateContent xmlns:mc="http://schemas.openxmlformats.org/markup-compatibility/2006">
+    <mc:Choice xmlns:p14="http://schemas.microsoft.com/office/powerpoint/2010/main" Requires="p14">
+      <p:transition spd="slow" p14:dur="2000"/>
+    </mc:Choice>
+    <mc:Fallback>
+      <p:transition spd="slow"/>
+    </mc:Fallback>
+  </mc:AlternateContent>
   <p:timing>
     <p:tnLst>
       <p:par>
@@ -12041,7 +11298,7 @@
 </p:sld>
 </file>
 
-<file path=ppt/slides/slide14.xml><?xml version="1.0" encoding="utf-8"?>
+<file path=ppt/slides/slide13.xml><?xml version="1.0" encoding="utf-8"?>
 <p:sld xmlns:a="http://schemas.openxmlformats.org/drawingml/2006/main" xmlns:r="http://schemas.openxmlformats.org/officeDocument/2006/relationships" xmlns:p="http://schemas.openxmlformats.org/presentationml/2006/main">
   <p:cSld>
     <p:spTree>
@@ -12319,7 +11576,7 @@
 </p:sld>
 </file>
 
-<file path=ppt/slides/slide15.xml><?xml version="1.0" encoding="utf-8"?>
+<file path=ppt/slides/slide14.xml><?xml version="1.0" encoding="utf-8"?>
 <p:sld xmlns:a="http://schemas.openxmlformats.org/drawingml/2006/main" xmlns:r="http://schemas.openxmlformats.org/officeDocument/2006/relationships" xmlns:p="http://schemas.openxmlformats.org/presentationml/2006/main" show="0">
   <p:cSld>
     <p:spTree>
@@ -12412,7 +11669,7 @@
 </p:sld>
 </file>
 
-<file path=ppt/slides/slide16.xml><?xml version="1.0" encoding="utf-8"?>
+<file path=ppt/slides/slide15.xml><?xml version="1.0" encoding="utf-8"?>
 <p:sld xmlns:a="http://schemas.openxmlformats.org/drawingml/2006/main" xmlns:r="http://schemas.openxmlformats.org/officeDocument/2006/relationships" xmlns:p="http://schemas.openxmlformats.org/presentationml/2006/main" show="0">
   <p:cSld>
     <p:spTree>
@@ -12505,7 +11762,7 @@
 </p:sld>
 </file>
 
-<file path=ppt/slides/slide17.xml><?xml version="1.0" encoding="utf-8"?>
+<file path=ppt/slides/slide16.xml><?xml version="1.0" encoding="utf-8"?>
 <p:sld xmlns:a="http://schemas.openxmlformats.org/drawingml/2006/main" xmlns:r="http://schemas.openxmlformats.org/officeDocument/2006/relationships" xmlns:p="http://schemas.openxmlformats.org/presentationml/2006/main" show="0">
   <p:cSld>
     <p:spTree>
@@ -12676,7 +11933,7 @@
 </p:sld>
 </file>
 
-<file path=ppt/slides/slide18.xml><?xml version="1.0" encoding="utf-8"?>
+<file path=ppt/slides/slide17.xml><?xml version="1.0" encoding="utf-8"?>
 <p:sld xmlns:a="http://schemas.openxmlformats.org/drawingml/2006/main" xmlns:r="http://schemas.openxmlformats.org/officeDocument/2006/relationships" xmlns:p="http://schemas.openxmlformats.org/presentationml/2006/main">
   <p:cSld>
     <p:spTree>
@@ -12907,7 +12164,7 @@
 </p:sld>
 </file>
 
-<file path=ppt/slides/slide19.xml><?xml version="1.0" encoding="utf-8"?>
+<file path=ppt/slides/slide18.xml><?xml version="1.0" encoding="utf-8"?>
 <p:sld xmlns:a="http://schemas.openxmlformats.org/drawingml/2006/main" xmlns:r="http://schemas.openxmlformats.org/officeDocument/2006/relationships" xmlns:p="http://schemas.openxmlformats.org/presentationml/2006/main">
   <p:cSld>
     <p:spTree>
@@ -13135,590 +12392,7 @@
 </p:sld>
 </file>
 
-<file path=ppt/slides/slide2.xml><?xml version="1.0" encoding="utf-8"?>
-<p:sld xmlns:a="http://schemas.openxmlformats.org/drawingml/2006/main" xmlns:r="http://schemas.openxmlformats.org/officeDocument/2006/relationships" xmlns:p="http://schemas.openxmlformats.org/presentationml/2006/main">
-  <p:cSld>
-    <p:spTree>
-      <p:nvGrpSpPr>
-        <p:cNvPr id="1" name=""/>
-        <p:cNvGrpSpPr/>
-        <p:nvPr/>
-      </p:nvGrpSpPr>
-      <p:grpSpPr>
-        <a:xfrm>
-          <a:off x="0" y="0"/>
-          <a:ext cx="0" cy="0"/>
-          <a:chOff x="0" y="0"/>
-          <a:chExt cx="0" cy="0"/>
-        </a:xfrm>
-      </p:grpSpPr>
-      <p:sp>
-        <p:nvSpPr>
-          <p:cNvPr id="10" name="Rectángulo 9"/>
-          <p:cNvSpPr/>
-          <p:nvPr/>
-        </p:nvSpPr>
-        <p:spPr>
-          <a:xfrm>
-            <a:off x="731520" y="3291840"/>
-            <a:ext cx="11082528" cy="3374136"/>
-          </a:xfrm>
-          <a:prstGeom prst="rect">
-            <a:avLst/>
-          </a:prstGeom>
-        </p:spPr>
-        <p:style>
-          <a:lnRef idx="2">
-            <a:schemeClr val="accent1">
-              <a:shade val="50000"/>
-            </a:schemeClr>
-          </a:lnRef>
-          <a:fillRef idx="1">
-            <a:schemeClr val="accent1"/>
-          </a:fillRef>
-          <a:effectRef idx="0">
-            <a:schemeClr val="accent1"/>
-          </a:effectRef>
-          <a:fontRef idx="minor">
-            <a:schemeClr val="lt1"/>
-          </a:fontRef>
-        </p:style>
-        <p:txBody>
-          <a:bodyPr rtlCol="0" anchor="ctr"/>
-          <a:lstStyle/>
-          <a:p>
-            <a:pPr algn="ctr"/>
-            <a:endParaRPr lang="en-US"/>
-          </a:p>
-        </p:txBody>
-      </p:sp>
-      <p:sp>
-        <p:nvSpPr>
-          <p:cNvPr id="2" name="Título 1"/>
-          <p:cNvSpPr>
-            <a:spLocks noGrp="1"/>
-          </p:cNvSpPr>
-          <p:nvPr>
-            <p:ph type="title"/>
-          </p:nvPr>
-        </p:nvSpPr>
-        <p:spPr/>
-        <p:txBody>
-          <a:bodyPr/>
-          <a:lstStyle/>
-          <a:p>
-            <a:endParaRPr lang="en-US" dirty="0"/>
-          </a:p>
-        </p:txBody>
-      </p:sp>
-      <p:pic>
-        <p:nvPicPr>
-          <p:cNvPr id="7" name="Marcador de contenido 6"/>
-          <p:cNvPicPr>
-            <a:picLocks noGrp="1" noChangeAspect="1"/>
-          </p:cNvPicPr>
-          <p:nvPr>
-            <p:ph idx="1"/>
-          </p:nvPr>
-        </p:nvPicPr>
-        <p:blipFill>
-          <a:blip r:embed="rId2">
-            <a:extLst>
-              <a:ext uri="{28A0092B-C50C-407E-A947-70E740481C1C}">
-                <a14:useLocalDpi xmlns:a14="http://schemas.microsoft.com/office/drawing/2010/main" val="0"/>
-              </a:ext>
-            </a:extLst>
-          </a:blip>
-          <a:stretch>
-            <a:fillRect/>
-          </a:stretch>
-        </p:blipFill>
-        <p:spPr>
-          <a:xfrm>
-            <a:off x="2157997" y="4143772"/>
-            <a:ext cx="2076056" cy="1905633"/>
-          </a:xfrm>
-        </p:spPr>
-      </p:pic>
-      <p:sp>
-        <p:nvSpPr>
-          <p:cNvPr id="4" name="Elipse 3"/>
-          <p:cNvSpPr/>
-          <p:nvPr/>
-        </p:nvSpPr>
-        <p:spPr>
-          <a:xfrm>
-            <a:off x="594360" y="337376"/>
-            <a:ext cx="2926080" cy="2579560"/>
-          </a:xfrm>
-          <a:prstGeom prst="ellipse">
-            <a:avLst/>
-          </a:prstGeom>
-        </p:spPr>
-        <p:style>
-          <a:lnRef idx="2">
-            <a:schemeClr val="accent2">
-              <a:shade val="50000"/>
-            </a:schemeClr>
-          </a:lnRef>
-          <a:fillRef idx="1">
-            <a:schemeClr val="accent2"/>
-          </a:fillRef>
-          <a:effectRef idx="0">
-            <a:schemeClr val="accent2"/>
-          </a:effectRef>
-          <a:fontRef idx="minor">
-            <a:schemeClr val="lt1"/>
-          </a:fontRef>
-        </p:style>
-        <p:txBody>
-          <a:bodyPr rtlCol="0" anchor="ctr"/>
-          <a:lstStyle/>
-          <a:p>
-            <a:pPr algn="ctr"/>
-            <a:r>
-              <a:rPr lang="es-MX" dirty="0" err="1" smtClean="0"/>
-              <a:t>Nutrient</a:t>
-            </a:r>
-            <a:r>
-              <a:rPr lang="es-MX" dirty="0" smtClean="0"/>
-              <a:t> </a:t>
-            </a:r>
-            <a:r>
-              <a:rPr lang="es-MX" dirty="0" err="1" smtClean="0"/>
-              <a:t>addition</a:t>
-            </a:r>
-            <a:r>
-              <a:rPr lang="es-MX" dirty="0" smtClean="0"/>
-              <a:t> </a:t>
-            </a:r>
-            <a:r>
-              <a:rPr lang="es-MX" dirty="0" err="1" smtClean="0"/>
-              <a:t>experiment</a:t>
-            </a:r>
-            <a:endParaRPr lang="es-MX" dirty="0" smtClean="0"/>
-          </a:p>
-          <a:p>
-            <a:pPr algn="ctr"/>
-            <a:endParaRPr lang="es-MX" dirty="0"/>
-          </a:p>
-          <a:p>
-            <a:pPr algn="ctr"/>
-            <a:r>
-              <a:rPr lang="es-MX" dirty="0" smtClean="0"/>
-              <a:t>N, P, N*P</a:t>
-            </a:r>
-            <a:endParaRPr lang="en-US" dirty="0"/>
-          </a:p>
-        </p:txBody>
-      </p:sp>
-      <p:sp>
-        <p:nvSpPr>
-          <p:cNvPr id="5" name="Elipse 4"/>
-          <p:cNvSpPr/>
-          <p:nvPr/>
-        </p:nvSpPr>
-        <p:spPr>
-          <a:xfrm>
-            <a:off x="4581144" y="337375"/>
-            <a:ext cx="2795016" cy="2491993"/>
-          </a:xfrm>
-          <a:prstGeom prst="ellipse">
-            <a:avLst/>
-          </a:prstGeom>
-        </p:spPr>
-        <p:style>
-          <a:lnRef idx="2">
-            <a:schemeClr val="accent6">
-              <a:shade val="50000"/>
-            </a:schemeClr>
-          </a:lnRef>
-          <a:fillRef idx="1">
-            <a:schemeClr val="accent6"/>
-          </a:fillRef>
-          <a:effectRef idx="0">
-            <a:schemeClr val="accent6"/>
-          </a:effectRef>
-          <a:fontRef idx="minor">
-            <a:schemeClr val="lt1"/>
-          </a:fontRef>
-        </p:style>
-        <p:txBody>
-          <a:bodyPr rtlCol="0" anchor="ctr"/>
-          <a:lstStyle/>
-          <a:p>
-            <a:pPr algn="ctr"/>
-            <a:r>
-              <a:rPr lang="es-MX" dirty="0" err="1" smtClean="0"/>
-              <a:t>Leaf</a:t>
-            </a:r>
-            <a:r>
-              <a:rPr lang="es-MX" dirty="0" smtClean="0"/>
-              <a:t> </a:t>
-            </a:r>
-            <a:r>
-              <a:rPr lang="es-MX" dirty="0" err="1" smtClean="0"/>
-              <a:t>functional</a:t>
-            </a:r>
-            <a:r>
-              <a:rPr lang="es-MX" dirty="0" smtClean="0"/>
-              <a:t> </a:t>
-            </a:r>
-            <a:r>
-              <a:rPr lang="es-MX" dirty="0" err="1" smtClean="0"/>
-              <a:t>traits</a:t>
-            </a:r>
-            <a:endParaRPr lang="es-MX" dirty="0" smtClean="0"/>
-          </a:p>
-          <a:p>
-            <a:pPr marL="285750" indent="-285750" algn="ctr">
-              <a:buFontTx/>
-              <a:buChar char="-"/>
-            </a:pPr>
-            <a:r>
-              <a:rPr lang="es-MX" sz="1200" dirty="0" err="1" smtClean="0"/>
-              <a:t>Thoughness</a:t>
-            </a:r>
-            <a:endParaRPr lang="es-MX" sz="1200" dirty="0" smtClean="0"/>
-          </a:p>
-          <a:p>
-            <a:pPr marL="285750" indent="-285750" algn="ctr">
-              <a:buFontTx/>
-              <a:buChar char="-"/>
-            </a:pPr>
-            <a:r>
-              <a:rPr lang="es-MX" sz="1200" dirty="0" err="1" smtClean="0"/>
-              <a:t>Thickness</a:t>
-            </a:r>
-            <a:endParaRPr lang="es-MX" sz="1200" dirty="0" smtClean="0"/>
-          </a:p>
-          <a:p>
-            <a:pPr marL="285750" indent="-285750" algn="ctr">
-              <a:buFontTx/>
-              <a:buChar char="-"/>
-            </a:pPr>
-            <a:r>
-              <a:rPr lang="es-MX" sz="1200" dirty="0" smtClean="0"/>
-              <a:t>SLA / LA</a:t>
-            </a:r>
-          </a:p>
-          <a:p>
-            <a:pPr marL="285750" indent="-285750" algn="ctr">
-              <a:buFontTx/>
-              <a:buChar char="-"/>
-            </a:pPr>
-            <a:r>
-              <a:rPr lang="es-MX" sz="1200" dirty="0" smtClean="0"/>
-              <a:t>Carea / </a:t>
-            </a:r>
-            <a:r>
-              <a:rPr lang="es-MX" sz="1200" dirty="0" err="1" smtClean="0"/>
-              <a:t>Narea</a:t>
-            </a:r>
-            <a:endParaRPr lang="es-MX" sz="1200" dirty="0" smtClean="0"/>
-          </a:p>
-          <a:p>
-            <a:pPr marL="285750" indent="-285750" algn="ctr">
-              <a:buFontTx/>
-              <a:buChar char="-"/>
-            </a:pPr>
-            <a:r>
-              <a:rPr lang="es-MX" sz="1200" dirty="0" err="1" smtClean="0"/>
-              <a:t>Leat</a:t>
-            </a:r>
-            <a:r>
-              <a:rPr lang="es-MX" sz="1200" dirty="0" smtClean="0"/>
-              <a:t> </a:t>
-            </a:r>
-            <a:r>
-              <a:rPr lang="es-MX" sz="1200" dirty="0" err="1" smtClean="0"/>
-              <a:t>water</a:t>
-            </a:r>
-            <a:r>
-              <a:rPr lang="es-MX" sz="1200" dirty="0" smtClean="0"/>
-              <a:t> </a:t>
-            </a:r>
-            <a:r>
-              <a:rPr lang="es-MX" sz="1200" dirty="0" err="1" smtClean="0"/>
-              <a:t>content</a:t>
-            </a:r>
-            <a:endParaRPr lang="en-US" sz="1200" dirty="0"/>
-          </a:p>
-        </p:txBody>
-      </p:sp>
-      <p:sp>
-        <p:nvSpPr>
-          <p:cNvPr id="6" name="Elipse 5"/>
-          <p:cNvSpPr/>
-          <p:nvPr/>
-        </p:nvSpPr>
-        <p:spPr>
-          <a:xfrm>
-            <a:off x="8357616" y="337375"/>
-            <a:ext cx="2896248" cy="2491993"/>
-          </a:xfrm>
-          <a:prstGeom prst="ellipse">
-            <a:avLst/>
-          </a:prstGeom>
-        </p:spPr>
-        <p:style>
-          <a:lnRef idx="2">
-            <a:schemeClr val="accent2">
-              <a:shade val="50000"/>
-            </a:schemeClr>
-          </a:lnRef>
-          <a:fillRef idx="1">
-            <a:schemeClr val="accent2"/>
-          </a:fillRef>
-          <a:effectRef idx="0">
-            <a:schemeClr val="accent2"/>
-          </a:effectRef>
-          <a:fontRef idx="minor">
-            <a:schemeClr val="lt1"/>
-          </a:fontRef>
-        </p:style>
-        <p:txBody>
-          <a:bodyPr rtlCol="0" anchor="ctr"/>
-          <a:lstStyle/>
-          <a:p>
-            <a:pPr algn="ctr"/>
-            <a:r>
-              <a:rPr lang="es-MX" dirty="0" err="1" smtClean="0"/>
-              <a:t>Climatic</a:t>
-            </a:r>
-            <a:r>
-              <a:rPr lang="es-MX" dirty="0" smtClean="0"/>
-              <a:t> – </a:t>
-            </a:r>
-            <a:r>
-              <a:rPr lang="es-MX" dirty="0" err="1" smtClean="0"/>
-              <a:t>Using</a:t>
-            </a:r>
-            <a:r>
-              <a:rPr lang="es-MX" dirty="0" smtClean="0"/>
-              <a:t> </a:t>
-            </a:r>
-            <a:r>
-              <a:rPr lang="es-MX" dirty="0" err="1" smtClean="0"/>
-              <a:t>Elevation</a:t>
-            </a:r>
-            <a:r>
-              <a:rPr lang="es-MX" dirty="0" smtClean="0"/>
-              <a:t> as proxy</a:t>
-            </a:r>
-          </a:p>
-          <a:p>
-            <a:pPr algn="ctr"/>
-            <a:r>
-              <a:rPr lang="es-MX" dirty="0" smtClean="0"/>
-              <a:t>1000, 2000, 3000</a:t>
-            </a:r>
-          </a:p>
-          <a:p>
-            <a:pPr algn="ctr"/>
-            <a:endParaRPr lang="en-US" dirty="0"/>
-          </a:p>
-        </p:txBody>
-      </p:sp>
-      <p:pic>
-        <p:nvPicPr>
-          <p:cNvPr id="8" name="Imagen 7"/>
-          <p:cNvPicPr>
-            <a:picLocks noChangeAspect="1"/>
-          </p:cNvPicPr>
-          <p:nvPr/>
-        </p:nvPicPr>
-        <p:blipFill>
-          <a:blip r:embed="rId3" cstate="print">
-            <a:extLst>
-              <a:ext uri="{28A0092B-C50C-407E-A947-70E740481C1C}">
-                <a14:useLocalDpi xmlns:a14="http://schemas.microsoft.com/office/drawing/2010/main" val="0"/>
-              </a:ext>
-            </a:extLst>
-          </a:blip>
-          <a:stretch>
-            <a:fillRect/>
-          </a:stretch>
-        </p:blipFill>
-        <p:spPr>
-          <a:xfrm>
-            <a:off x="6606264" y="3721896"/>
-            <a:ext cx="4887792" cy="2749383"/>
-          </a:xfrm>
-          <a:prstGeom prst="rect">
-            <a:avLst/>
-          </a:prstGeom>
-        </p:spPr>
-      </p:pic>
-      <p:sp>
-        <p:nvSpPr>
-          <p:cNvPr id="9" name="CuadroTexto 8"/>
-          <p:cNvSpPr txBox="1"/>
-          <p:nvPr/>
-        </p:nvSpPr>
-        <p:spPr>
-          <a:xfrm>
-            <a:off x="4953000" y="4727256"/>
-            <a:ext cx="1389888" cy="369332"/>
-          </a:xfrm>
-          <a:prstGeom prst="rect">
-            <a:avLst/>
-          </a:prstGeom>
-          <a:noFill/>
-        </p:spPr>
-        <p:txBody>
-          <a:bodyPr wrap="square" rtlCol="0">
-            <a:spAutoFit/>
-          </a:bodyPr>
-          <a:lstStyle/>
-          <a:p>
-            <a:r>
-              <a:rPr lang="es-MX" dirty="0" err="1" smtClean="0"/>
-              <a:t>iWUE</a:t>
-            </a:r>
-            <a:r>
-              <a:rPr lang="es-MX" dirty="0" smtClean="0"/>
-              <a:t> = A/g</a:t>
-            </a:r>
-            <a:endParaRPr lang="en-US" dirty="0"/>
-          </a:p>
-        </p:txBody>
-      </p:sp>
-      <p:sp>
-        <p:nvSpPr>
-          <p:cNvPr id="13" name="Flecha abajo 12"/>
-          <p:cNvSpPr/>
-          <p:nvPr/>
-        </p:nvSpPr>
-        <p:spPr>
-          <a:xfrm>
-            <a:off x="1476756" y="2462924"/>
-            <a:ext cx="1161288" cy="1305944"/>
-          </a:xfrm>
-          <a:prstGeom prst="downArrow">
-            <a:avLst/>
-          </a:prstGeom>
-        </p:spPr>
-        <p:style>
-          <a:lnRef idx="2">
-            <a:schemeClr val="dk1"/>
-          </a:lnRef>
-          <a:fillRef idx="1">
-            <a:schemeClr val="lt1"/>
-          </a:fillRef>
-          <a:effectRef idx="0">
-            <a:schemeClr val="dk1"/>
-          </a:effectRef>
-          <a:fontRef idx="minor">
-            <a:schemeClr val="dk1"/>
-          </a:fontRef>
-        </p:style>
-        <p:txBody>
-          <a:bodyPr rtlCol="0" anchor="ctr"/>
-          <a:lstStyle/>
-          <a:p>
-            <a:pPr algn="ctr"/>
-            <a:endParaRPr lang="en-US"/>
-          </a:p>
-        </p:txBody>
-      </p:sp>
-      <p:sp>
-        <p:nvSpPr>
-          <p:cNvPr id="14" name="Flecha abajo 13"/>
-          <p:cNvSpPr/>
-          <p:nvPr/>
-        </p:nvSpPr>
-        <p:spPr>
-          <a:xfrm>
-            <a:off x="5515356" y="2537104"/>
-            <a:ext cx="1161288" cy="1305944"/>
-          </a:xfrm>
-          <a:prstGeom prst="downArrow">
-            <a:avLst/>
-          </a:prstGeom>
-        </p:spPr>
-        <p:style>
-          <a:lnRef idx="2">
-            <a:schemeClr val="dk1"/>
-          </a:lnRef>
-          <a:fillRef idx="1">
-            <a:schemeClr val="lt1"/>
-          </a:fillRef>
-          <a:effectRef idx="0">
-            <a:schemeClr val="dk1"/>
-          </a:effectRef>
-          <a:fontRef idx="minor">
-            <a:schemeClr val="dk1"/>
-          </a:fontRef>
-        </p:style>
-        <p:txBody>
-          <a:bodyPr rtlCol="0" anchor="ctr"/>
-          <a:lstStyle/>
-          <a:p>
-            <a:pPr algn="ctr"/>
-            <a:endParaRPr lang="en-US"/>
-          </a:p>
-        </p:txBody>
-      </p:sp>
-      <p:sp>
-        <p:nvSpPr>
-          <p:cNvPr id="15" name="Flecha abajo 14"/>
-          <p:cNvSpPr/>
-          <p:nvPr/>
-        </p:nvSpPr>
-        <p:spPr>
-          <a:xfrm>
-            <a:off x="9261372" y="2324000"/>
-            <a:ext cx="1161288" cy="1305944"/>
-          </a:xfrm>
-          <a:prstGeom prst="downArrow">
-            <a:avLst/>
-          </a:prstGeom>
-        </p:spPr>
-        <p:style>
-          <a:lnRef idx="2">
-            <a:schemeClr val="dk1"/>
-          </a:lnRef>
-          <a:fillRef idx="1">
-            <a:schemeClr val="lt1"/>
-          </a:fillRef>
-          <a:effectRef idx="0">
-            <a:schemeClr val="dk1"/>
-          </a:effectRef>
-          <a:fontRef idx="minor">
-            <a:schemeClr val="dk1"/>
-          </a:fontRef>
-        </p:style>
-        <p:txBody>
-          <a:bodyPr rtlCol="0" anchor="ctr"/>
-          <a:lstStyle/>
-          <a:p>
-            <a:pPr algn="ctr"/>
-            <a:endParaRPr lang="en-US"/>
-          </a:p>
-        </p:txBody>
-      </p:sp>
-    </p:spTree>
-    <p:extLst>
-      <p:ext uri="{BB962C8B-B14F-4D97-AF65-F5344CB8AC3E}">
-        <p14:creationId xmlns:p14="http://schemas.microsoft.com/office/powerpoint/2010/main" val="1733027128"/>
-      </p:ext>
-    </p:extLst>
-  </p:cSld>
-  <p:clrMapOvr>
-    <a:masterClrMapping/>
-  </p:clrMapOvr>
-  <p:timing>
-    <p:tnLst>
-      <p:par>
-        <p:cTn id="1" dur="indefinite" restart="never" nodeType="tmRoot"/>
-      </p:par>
-    </p:tnLst>
-  </p:timing>
-</p:sld>
-</file>
-
-<file path=ppt/slides/slide20.xml><?xml version="1.0" encoding="utf-8"?>
+<file path=ppt/slides/slide19.xml><?xml version="1.0" encoding="utf-8"?>
 <p:sld xmlns:a="http://schemas.openxmlformats.org/drawingml/2006/main" xmlns:r="http://schemas.openxmlformats.org/officeDocument/2006/relationships" xmlns:p="http://schemas.openxmlformats.org/presentationml/2006/main">
   <p:cSld>
     <p:spTree>
@@ -16923,7 +15597,590 @@
 </p:sld>
 </file>
 
-<file path=ppt/slides/slide21.xml><?xml version="1.0" encoding="utf-8"?>
+<file path=ppt/slides/slide2.xml><?xml version="1.0" encoding="utf-8"?>
+<p:sld xmlns:a="http://schemas.openxmlformats.org/drawingml/2006/main" xmlns:r="http://schemas.openxmlformats.org/officeDocument/2006/relationships" xmlns:p="http://schemas.openxmlformats.org/presentationml/2006/main">
+  <p:cSld>
+    <p:spTree>
+      <p:nvGrpSpPr>
+        <p:cNvPr id="1" name=""/>
+        <p:cNvGrpSpPr/>
+        <p:nvPr/>
+      </p:nvGrpSpPr>
+      <p:grpSpPr>
+        <a:xfrm>
+          <a:off x="0" y="0"/>
+          <a:ext cx="0" cy="0"/>
+          <a:chOff x="0" y="0"/>
+          <a:chExt cx="0" cy="0"/>
+        </a:xfrm>
+      </p:grpSpPr>
+      <p:sp>
+        <p:nvSpPr>
+          <p:cNvPr id="10" name="Rectángulo 9"/>
+          <p:cNvSpPr/>
+          <p:nvPr/>
+        </p:nvSpPr>
+        <p:spPr>
+          <a:xfrm>
+            <a:off x="731520" y="3291840"/>
+            <a:ext cx="11082528" cy="3374136"/>
+          </a:xfrm>
+          <a:prstGeom prst="rect">
+            <a:avLst/>
+          </a:prstGeom>
+        </p:spPr>
+        <p:style>
+          <a:lnRef idx="2">
+            <a:schemeClr val="accent1">
+              <a:shade val="50000"/>
+            </a:schemeClr>
+          </a:lnRef>
+          <a:fillRef idx="1">
+            <a:schemeClr val="accent1"/>
+          </a:fillRef>
+          <a:effectRef idx="0">
+            <a:schemeClr val="accent1"/>
+          </a:effectRef>
+          <a:fontRef idx="minor">
+            <a:schemeClr val="lt1"/>
+          </a:fontRef>
+        </p:style>
+        <p:txBody>
+          <a:bodyPr rtlCol="0" anchor="ctr"/>
+          <a:lstStyle/>
+          <a:p>
+            <a:pPr algn="ctr"/>
+            <a:endParaRPr lang="en-US"/>
+          </a:p>
+        </p:txBody>
+      </p:sp>
+      <p:sp>
+        <p:nvSpPr>
+          <p:cNvPr id="2" name="Título 1"/>
+          <p:cNvSpPr>
+            <a:spLocks noGrp="1"/>
+          </p:cNvSpPr>
+          <p:nvPr>
+            <p:ph type="title"/>
+          </p:nvPr>
+        </p:nvSpPr>
+        <p:spPr/>
+        <p:txBody>
+          <a:bodyPr/>
+          <a:lstStyle/>
+          <a:p>
+            <a:endParaRPr lang="en-US" dirty="0"/>
+          </a:p>
+        </p:txBody>
+      </p:sp>
+      <p:pic>
+        <p:nvPicPr>
+          <p:cNvPr id="7" name="Marcador de contenido 6"/>
+          <p:cNvPicPr>
+            <a:picLocks noGrp="1" noChangeAspect="1"/>
+          </p:cNvPicPr>
+          <p:nvPr>
+            <p:ph idx="1"/>
+          </p:nvPr>
+        </p:nvPicPr>
+        <p:blipFill>
+          <a:blip r:embed="rId2">
+            <a:extLst>
+              <a:ext uri="{28A0092B-C50C-407E-A947-70E740481C1C}">
+                <a14:useLocalDpi xmlns:a14="http://schemas.microsoft.com/office/drawing/2010/main" val="0"/>
+              </a:ext>
+            </a:extLst>
+          </a:blip>
+          <a:stretch>
+            <a:fillRect/>
+          </a:stretch>
+        </p:blipFill>
+        <p:spPr>
+          <a:xfrm>
+            <a:off x="2157997" y="4143772"/>
+            <a:ext cx="2076056" cy="1905633"/>
+          </a:xfrm>
+        </p:spPr>
+      </p:pic>
+      <p:sp>
+        <p:nvSpPr>
+          <p:cNvPr id="4" name="Elipse 3"/>
+          <p:cNvSpPr/>
+          <p:nvPr/>
+        </p:nvSpPr>
+        <p:spPr>
+          <a:xfrm>
+            <a:off x="594360" y="337376"/>
+            <a:ext cx="2926080" cy="2579560"/>
+          </a:xfrm>
+          <a:prstGeom prst="ellipse">
+            <a:avLst/>
+          </a:prstGeom>
+        </p:spPr>
+        <p:style>
+          <a:lnRef idx="2">
+            <a:schemeClr val="accent2">
+              <a:shade val="50000"/>
+            </a:schemeClr>
+          </a:lnRef>
+          <a:fillRef idx="1">
+            <a:schemeClr val="accent2"/>
+          </a:fillRef>
+          <a:effectRef idx="0">
+            <a:schemeClr val="accent2"/>
+          </a:effectRef>
+          <a:fontRef idx="minor">
+            <a:schemeClr val="lt1"/>
+          </a:fontRef>
+        </p:style>
+        <p:txBody>
+          <a:bodyPr rtlCol="0" anchor="ctr"/>
+          <a:lstStyle/>
+          <a:p>
+            <a:pPr algn="ctr"/>
+            <a:r>
+              <a:rPr lang="es-MX" dirty="0" err="1" smtClean="0"/>
+              <a:t>Nutrient</a:t>
+            </a:r>
+            <a:r>
+              <a:rPr lang="es-MX" dirty="0" smtClean="0"/>
+              <a:t> </a:t>
+            </a:r>
+            <a:r>
+              <a:rPr lang="es-MX" dirty="0" err="1" smtClean="0"/>
+              <a:t>addition</a:t>
+            </a:r>
+            <a:r>
+              <a:rPr lang="es-MX" dirty="0" smtClean="0"/>
+              <a:t> </a:t>
+            </a:r>
+            <a:r>
+              <a:rPr lang="es-MX" dirty="0" err="1" smtClean="0"/>
+              <a:t>experiment</a:t>
+            </a:r>
+            <a:endParaRPr lang="es-MX" dirty="0" smtClean="0"/>
+          </a:p>
+          <a:p>
+            <a:pPr algn="ctr"/>
+            <a:endParaRPr lang="es-MX" dirty="0"/>
+          </a:p>
+          <a:p>
+            <a:pPr algn="ctr"/>
+            <a:r>
+              <a:rPr lang="es-MX" dirty="0" smtClean="0"/>
+              <a:t>N, P, N*P</a:t>
+            </a:r>
+            <a:endParaRPr lang="en-US" dirty="0"/>
+          </a:p>
+        </p:txBody>
+      </p:sp>
+      <p:sp>
+        <p:nvSpPr>
+          <p:cNvPr id="5" name="Elipse 4"/>
+          <p:cNvSpPr/>
+          <p:nvPr/>
+        </p:nvSpPr>
+        <p:spPr>
+          <a:xfrm>
+            <a:off x="4581144" y="337375"/>
+            <a:ext cx="2795016" cy="2491993"/>
+          </a:xfrm>
+          <a:prstGeom prst="ellipse">
+            <a:avLst/>
+          </a:prstGeom>
+        </p:spPr>
+        <p:style>
+          <a:lnRef idx="2">
+            <a:schemeClr val="accent6">
+              <a:shade val="50000"/>
+            </a:schemeClr>
+          </a:lnRef>
+          <a:fillRef idx="1">
+            <a:schemeClr val="accent6"/>
+          </a:fillRef>
+          <a:effectRef idx="0">
+            <a:schemeClr val="accent6"/>
+          </a:effectRef>
+          <a:fontRef idx="minor">
+            <a:schemeClr val="lt1"/>
+          </a:fontRef>
+        </p:style>
+        <p:txBody>
+          <a:bodyPr rtlCol="0" anchor="ctr"/>
+          <a:lstStyle/>
+          <a:p>
+            <a:pPr algn="ctr"/>
+            <a:r>
+              <a:rPr lang="es-MX" dirty="0" err="1" smtClean="0"/>
+              <a:t>Leaf</a:t>
+            </a:r>
+            <a:r>
+              <a:rPr lang="es-MX" dirty="0" smtClean="0"/>
+              <a:t> </a:t>
+            </a:r>
+            <a:r>
+              <a:rPr lang="es-MX" dirty="0" err="1" smtClean="0"/>
+              <a:t>functional</a:t>
+            </a:r>
+            <a:r>
+              <a:rPr lang="es-MX" dirty="0" smtClean="0"/>
+              <a:t> </a:t>
+            </a:r>
+            <a:r>
+              <a:rPr lang="es-MX" dirty="0" err="1" smtClean="0"/>
+              <a:t>traits</a:t>
+            </a:r>
+            <a:endParaRPr lang="es-MX" dirty="0" smtClean="0"/>
+          </a:p>
+          <a:p>
+            <a:pPr marL="285750" indent="-285750" algn="ctr">
+              <a:buFontTx/>
+              <a:buChar char="-"/>
+            </a:pPr>
+            <a:r>
+              <a:rPr lang="es-MX" sz="1200" dirty="0" err="1" smtClean="0"/>
+              <a:t>Thoughness</a:t>
+            </a:r>
+            <a:endParaRPr lang="es-MX" sz="1200" dirty="0" smtClean="0"/>
+          </a:p>
+          <a:p>
+            <a:pPr marL="285750" indent="-285750" algn="ctr">
+              <a:buFontTx/>
+              <a:buChar char="-"/>
+            </a:pPr>
+            <a:r>
+              <a:rPr lang="es-MX" sz="1200" dirty="0" err="1" smtClean="0"/>
+              <a:t>Thickness</a:t>
+            </a:r>
+            <a:endParaRPr lang="es-MX" sz="1200" dirty="0" smtClean="0"/>
+          </a:p>
+          <a:p>
+            <a:pPr marL="285750" indent="-285750" algn="ctr">
+              <a:buFontTx/>
+              <a:buChar char="-"/>
+            </a:pPr>
+            <a:r>
+              <a:rPr lang="es-MX" sz="1200" dirty="0" smtClean="0"/>
+              <a:t>SLA / LA</a:t>
+            </a:r>
+          </a:p>
+          <a:p>
+            <a:pPr marL="285750" indent="-285750" algn="ctr">
+              <a:buFontTx/>
+              <a:buChar char="-"/>
+            </a:pPr>
+            <a:r>
+              <a:rPr lang="es-MX" sz="1200" dirty="0" smtClean="0"/>
+              <a:t>Carea / </a:t>
+            </a:r>
+            <a:r>
+              <a:rPr lang="es-MX" sz="1200" dirty="0" err="1" smtClean="0"/>
+              <a:t>Narea</a:t>
+            </a:r>
+            <a:endParaRPr lang="es-MX" sz="1200" dirty="0" smtClean="0"/>
+          </a:p>
+          <a:p>
+            <a:pPr marL="285750" indent="-285750" algn="ctr">
+              <a:buFontTx/>
+              <a:buChar char="-"/>
+            </a:pPr>
+            <a:r>
+              <a:rPr lang="es-MX" sz="1200" dirty="0" err="1" smtClean="0"/>
+              <a:t>Leat</a:t>
+            </a:r>
+            <a:r>
+              <a:rPr lang="es-MX" sz="1200" dirty="0" smtClean="0"/>
+              <a:t> </a:t>
+            </a:r>
+            <a:r>
+              <a:rPr lang="es-MX" sz="1200" dirty="0" err="1" smtClean="0"/>
+              <a:t>water</a:t>
+            </a:r>
+            <a:r>
+              <a:rPr lang="es-MX" sz="1200" dirty="0" smtClean="0"/>
+              <a:t> </a:t>
+            </a:r>
+            <a:r>
+              <a:rPr lang="es-MX" sz="1200" dirty="0" err="1" smtClean="0"/>
+              <a:t>content</a:t>
+            </a:r>
+            <a:endParaRPr lang="en-US" sz="1200" dirty="0"/>
+          </a:p>
+        </p:txBody>
+      </p:sp>
+      <p:sp>
+        <p:nvSpPr>
+          <p:cNvPr id="6" name="Elipse 5"/>
+          <p:cNvSpPr/>
+          <p:nvPr/>
+        </p:nvSpPr>
+        <p:spPr>
+          <a:xfrm>
+            <a:off x="8357616" y="337375"/>
+            <a:ext cx="2896248" cy="2491993"/>
+          </a:xfrm>
+          <a:prstGeom prst="ellipse">
+            <a:avLst/>
+          </a:prstGeom>
+        </p:spPr>
+        <p:style>
+          <a:lnRef idx="2">
+            <a:schemeClr val="accent2">
+              <a:shade val="50000"/>
+            </a:schemeClr>
+          </a:lnRef>
+          <a:fillRef idx="1">
+            <a:schemeClr val="accent2"/>
+          </a:fillRef>
+          <a:effectRef idx="0">
+            <a:schemeClr val="accent2"/>
+          </a:effectRef>
+          <a:fontRef idx="minor">
+            <a:schemeClr val="lt1"/>
+          </a:fontRef>
+        </p:style>
+        <p:txBody>
+          <a:bodyPr rtlCol="0" anchor="ctr"/>
+          <a:lstStyle/>
+          <a:p>
+            <a:pPr algn="ctr"/>
+            <a:r>
+              <a:rPr lang="es-MX" dirty="0" err="1" smtClean="0"/>
+              <a:t>Climatic</a:t>
+            </a:r>
+            <a:r>
+              <a:rPr lang="es-MX" dirty="0" smtClean="0"/>
+              <a:t> – </a:t>
+            </a:r>
+            <a:r>
+              <a:rPr lang="es-MX" dirty="0" err="1" smtClean="0"/>
+              <a:t>Using</a:t>
+            </a:r>
+            <a:r>
+              <a:rPr lang="es-MX" dirty="0" smtClean="0"/>
+              <a:t> </a:t>
+            </a:r>
+            <a:r>
+              <a:rPr lang="es-MX" dirty="0" err="1" smtClean="0"/>
+              <a:t>Elevation</a:t>
+            </a:r>
+            <a:r>
+              <a:rPr lang="es-MX" dirty="0" smtClean="0"/>
+              <a:t> as proxy</a:t>
+            </a:r>
+          </a:p>
+          <a:p>
+            <a:pPr algn="ctr"/>
+            <a:r>
+              <a:rPr lang="es-MX" dirty="0" smtClean="0"/>
+              <a:t>1000, 2000, 3000</a:t>
+            </a:r>
+          </a:p>
+          <a:p>
+            <a:pPr algn="ctr"/>
+            <a:endParaRPr lang="en-US" dirty="0"/>
+          </a:p>
+        </p:txBody>
+      </p:sp>
+      <p:pic>
+        <p:nvPicPr>
+          <p:cNvPr id="8" name="Imagen 7"/>
+          <p:cNvPicPr>
+            <a:picLocks noChangeAspect="1"/>
+          </p:cNvPicPr>
+          <p:nvPr/>
+        </p:nvPicPr>
+        <p:blipFill>
+          <a:blip r:embed="rId3" cstate="print">
+            <a:extLst>
+              <a:ext uri="{28A0092B-C50C-407E-A947-70E740481C1C}">
+                <a14:useLocalDpi xmlns:a14="http://schemas.microsoft.com/office/drawing/2010/main" val="0"/>
+              </a:ext>
+            </a:extLst>
+          </a:blip>
+          <a:stretch>
+            <a:fillRect/>
+          </a:stretch>
+        </p:blipFill>
+        <p:spPr>
+          <a:xfrm>
+            <a:off x="6606264" y="3721896"/>
+            <a:ext cx="4887792" cy="2749383"/>
+          </a:xfrm>
+          <a:prstGeom prst="rect">
+            <a:avLst/>
+          </a:prstGeom>
+        </p:spPr>
+      </p:pic>
+      <p:sp>
+        <p:nvSpPr>
+          <p:cNvPr id="9" name="CuadroTexto 8"/>
+          <p:cNvSpPr txBox="1"/>
+          <p:nvPr/>
+        </p:nvSpPr>
+        <p:spPr>
+          <a:xfrm>
+            <a:off x="4953000" y="4727256"/>
+            <a:ext cx="1389888" cy="369332"/>
+          </a:xfrm>
+          <a:prstGeom prst="rect">
+            <a:avLst/>
+          </a:prstGeom>
+          <a:noFill/>
+        </p:spPr>
+        <p:txBody>
+          <a:bodyPr wrap="square" rtlCol="0">
+            <a:spAutoFit/>
+          </a:bodyPr>
+          <a:lstStyle/>
+          <a:p>
+            <a:r>
+              <a:rPr lang="es-MX" dirty="0" err="1" smtClean="0"/>
+              <a:t>iWUE</a:t>
+            </a:r>
+            <a:r>
+              <a:rPr lang="es-MX" dirty="0" smtClean="0"/>
+              <a:t> = A/g</a:t>
+            </a:r>
+            <a:endParaRPr lang="en-US" dirty="0"/>
+          </a:p>
+        </p:txBody>
+      </p:sp>
+      <p:sp>
+        <p:nvSpPr>
+          <p:cNvPr id="13" name="Flecha abajo 12"/>
+          <p:cNvSpPr/>
+          <p:nvPr/>
+        </p:nvSpPr>
+        <p:spPr>
+          <a:xfrm>
+            <a:off x="1476756" y="2462924"/>
+            <a:ext cx="1161288" cy="1305944"/>
+          </a:xfrm>
+          <a:prstGeom prst="downArrow">
+            <a:avLst/>
+          </a:prstGeom>
+        </p:spPr>
+        <p:style>
+          <a:lnRef idx="2">
+            <a:schemeClr val="dk1"/>
+          </a:lnRef>
+          <a:fillRef idx="1">
+            <a:schemeClr val="lt1"/>
+          </a:fillRef>
+          <a:effectRef idx="0">
+            <a:schemeClr val="dk1"/>
+          </a:effectRef>
+          <a:fontRef idx="minor">
+            <a:schemeClr val="dk1"/>
+          </a:fontRef>
+        </p:style>
+        <p:txBody>
+          <a:bodyPr rtlCol="0" anchor="ctr"/>
+          <a:lstStyle/>
+          <a:p>
+            <a:pPr algn="ctr"/>
+            <a:endParaRPr lang="en-US"/>
+          </a:p>
+        </p:txBody>
+      </p:sp>
+      <p:sp>
+        <p:nvSpPr>
+          <p:cNvPr id="14" name="Flecha abajo 13"/>
+          <p:cNvSpPr/>
+          <p:nvPr/>
+        </p:nvSpPr>
+        <p:spPr>
+          <a:xfrm>
+            <a:off x="5515356" y="2537104"/>
+            <a:ext cx="1161288" cy="1305944"/>
+          </a:xfrm>
+          <a:prstGeom prst="downArrow">
+            <a:avLst/>
+          </a:prstGeom>
+        </p:spPr>
+        <p:style>
+          <a:lnRef idx="2">
+            <a:schemeClr val="dk1"/>
+          </a:lnRef>
+          <a:fillRef idx="1">
+            <a:schemeClr val="lt1"/>
+          </a:fillRef>
+          <a:effectRef idx="0">
+            <a:schemeClr val="dk1"/>
+          </a:effectRef>
+          <a:fontRef idx="minor">
+            <a:schemeClr val="dk1"/>
+          </a:fontRef>
+        </p:style>
+        <p:txBody>
+          <a:bodyPr rtlCol="0" anchor="ctr"/>
+          <a:lstStyle/>
+          <a:p>
+            <a:pPr algn="ctr"/>
+            <a:endParaRPr lang="en-US"/>
+          </a:p>
+        </p:txBody>
+      </p:sp>
+      <p:sp>
+        <p:nvSpPr>
+          <p:cNvPr id="15" name="Flecha abajo 14"/>
+          <p:cNvSpPr/>
+          <p:nvPr/>
+        </p:nvSpPr>
+        <p:spPr>
+          <a:xfrm>
+            <a:off x="9261372" y="2324000"/>
+            <a:ext cx="1161288" cy="1305944"/>
+          </a:xfrm>
+          <a:prstGeom prst="downArrow">
+            <a:avLst/>
+          </a:prstGeom>
+        </p:spPr>
+        <p:style>
+          <a:lnRef idx="2">
+            <a:schemeClr val="dk1"/>
+          </a:lnRef>
+          <a:fillRef idx="1">
+            <a:schemeClr val="lt1"/>
+          </a:fillRef>
+          <a:effectRef idx="0">
+            <a:schemeClr val="dk1"/>
+          </a:effectRef>
+          <a:fontRef idx="minor">
+            <a:schemeClr val="dk1"/>
+          </a:fontRef>
+        </p:style>
+        <p:txBody>
+          <a:bodyPr rtlCol="0" anchor="ctr"/>
+          <a:lstStyle/>
+          <a:p>
+            <a:pPr algn="ctr"/>
+            <a:endParaRPr lang="en-US"/>
+          </a:p>
+        </p:txBody>
+      </p:sp>
+    </p:spTree>
+    <p:extLst>
+      <p:ext uri="{BB962C8B-B14F-4D97-AF65-F5344CB8AC3E}">
+        <p14:creationId xmlns:p14="http://schemas.microsoft.com/office/powerpoint/2010/main" val="1733027128"/>
+      </p:ext>
+    </p:extLst>
+  </p:cSld>
+  <p:clrMapOvr>
+    <a:masterClrMapping/>
+  </p:clrMapOvr>
+  <p:timing>
+    <p:tnLst>
+      <p:par>
+        <p:cTn id="1" dur="indefinite" restart="never" nodeType="tmRoot"/>
+      </p:par>
+    </p:tnLst>
+  </p:timing>
+</p:sld>
+</file>
+
+<file path=ppt/slides/slide20.xml><?xml version="1.0" encoding="utf-8"?>
 <p:sld xmlns:a="http://schemas.openxmlformats.org/drawingml/2006/main" xmlns:r="http://schemas.openxmlformats.org/officeDocument/2006/relationships" xmlns:p="http://schemas.openxmlformats.org/presentationml/2006/main" show="0">
   <p:cSld>
     <p:spTree>
@@ -17036,7 +16293,7 @@
 </p:sld>
 </file>
 
-<file path=ppt/slides/slide22.xml><?xml version="1.0" encoding="utf-8"?>
+<file path=ppt/slides/slide21.xml><?xml version="1.0" encoding="utf-8"?>
 <p:sld xmlns:a="http://schemas.openxmlformats.org/drawingml/2006/main" xmlns:r="http://schemas.openxmlformats.org/officeDocument/2006/relationships" xmlns:p="http://schemas.openxmlformats.org/presentationml/2006/main" show="0">
   <p:cSld>
     <p:spTree>
@@ -17145,7 +16402,7 @@
 </p:sld>
 </file>
 
-<file path=ppt/slides/slide23.xml><?xml version="1.0" encoding="utf-8"?>
+<file path=ppt/slides/slide22.xml><?xml version="1.0" encoding="utf-8"?>
 <p:sld xmlns:a="http://schemas.openxmlformats.org/drawingml/2006/main" xmlns:r="http://schemas.openxmlformats.org/officeDocument/2006/relationships" xmlns:p="http://schemas.openxmlformats.org/presentationml/2006/main">
   <p:cSld>
     <p:spTree>
@@ -17736,7 +16993,7 @@
 </p:sld>
 </file>
 
-<file path=ppt/slides/slide24.xml><?xml version="1.0" encoding="utf-8"?>
+<file path=ppt/slides/slide23.xml><?xml version="1.0" encoding="utf-8"?>
 <p:sld xmlns:a="http://schemas.openxmlformats.org/drawingml/2006/main" xmlns:r="http://schemas.openxmlformats.org/officeDocument/2006/relationships" xmlns:p="http://schemas.openxmlformats.org/presentationml/2006/main">
   <p:cSld>
     <p:spTree>
@@ -18102,7 +17359,7 @@
 </p:sld>
 </file>
 
-<file path=ppt/slides/slide25.xml><?xml version="1.0" encoding="utf-8"?>
+<file path=ppt/slides/slide24.xml><?xml version="1.0" encoding="utf-8"?>
 <p:sld xmlns:a="http://schemas.openxmlformats.org/drawingml/2006/main" xmlns:r="http://schemas.openxmlformats.org/officeDocument/2006/relationships" xmlns:p="http://schemas.openxmlformats.org/presentationml/2006/main">
   <p:cSld>
     <p:spTree>
@@ -18205,7 +17462,7 @@
 </p:sld>
 </file>
 
-<file path=ppt/slides/slide26.xml><?xml version="1.0" encoding="utf-8"?>
+<file path=ppt/slides/slide25.xml><?xml version="1.0" encoding="utf-8"?>
 <p:sld xmlns:a="http://schemas.openxmlformats.org/drawingml/2006/main" xmlns:r="http://schemas.openxmlformats.org/officeDocument/2006/relationships" xmlns:p="http://schemas.openxmlformats.org/presentationml/2006/main">
   <p:cSld>
     <p:spTree>
@@ -18352,7 +17609,7 @@
 </p:sld>
 </file>
 
-<file path=ppt/slides/slide27.xml><?xml version="1.0" encoding="utf-8"?>
+<file path=ppt/slides/slide26.xml><?xml version="1.0" encoding="utf-8"?>
 <p:sld xmlns:a="http://schemas.openxmlformats.org/drawingml/2006/main" xmlns:r="http://schemas.openxmlformats.org/officeDocument/2006/relationships" xmlns:p="http://schemas.openxmlformats.org/presentationml/2006/main">
   <p:cSld>
     <p:spTree>
@@ -18706,7 +17963,7 @@
 </p:sld>
 </file>
 
-<file path=ppt/slides/slide28.xml><?xml version="1.0" encoding="utf-8"?>
+<file path=ppt/slides/slide27.xml><?xml version="1.0" encoding="utf-8"?>
 <p:sld xmlns:a="http://schemas.openxmlformats.org/drawingml/2006/main" xmlns:r="http://schemas.openxmlformats.org/officeDocument/2006/relationships" xmlns:p="http://schemas.openxmlformats.org/presentationml/2006/main">
   <p:cSld>
     <p:spTree>
@@ -18812,7 +18069,7 @@
 </p:sld>
 </file>
 
-<file path=ppt/slides/slide29.xml><?xml version="1.0" encoding="utf-8"?>
+<file path=ppt/slides/slide28.xml><?xml version="1.0" encoding="utf-8"?>
 <p:sld xmlns:a="http://schemas.openxmlformats.org/drawingml/2006/main" xmlns:r="http://schemas.openxmlformats.org/officeDocument/2006/relationships" xmlns:p="http://schemas.openxmlformats.org/presentationml/2006/main" show="0">
   <p:cSld>
     <p:spTree>
@@ -19185,6 +18442,113 @@
 </p:sld>
 </file>
 
+<file path=ppt/slides/slide29.xml><?xml version="1.0" encoding="utf-8"?>
+<p:sld xmlns:a="http://schemas.openxmlformats.org/drawingml/2006/main" xmlns:r="http://schemas.openxmlformats.org/officeDocument/2006/relationships" xmlns:p="http://schemas.openxmlformats.org/presentationml/2006/main">
+  <p:cSld>
+    <p:spTree>
+      <p:nvGrpSpPr>
+        <p:cNvPr id="1" name=""/>
+        <p:cNvGrpSpPr/>
+        <p:nvPr/>
+      </p:nvGrpSpPr>
+      <p:grpSpPr>
+        <a:xfrm>
+          <a:off x="0" y="0"/>
+          <a:ext cx="0" cy="0"/>
+          <a:chOff x="0" y="0"/>
+          <a:chExt cx="0" cy="0"/>
+        </a:xfrm>
+      </p:grpSpPr>
+      <p:sp>
+        <p:nvSpPr>
+          <p:cNvPr id="2" name="Título 1"/>
+          <p:cNvSpPr>
+            <a:spLocks noGrp="1"/>
+          </p:cNvSpPr>
+          <p:nvPr>
+            <p:ph type="title"/>
+          </p:nvPr>
+        </p:nvSpPr>
+        <p:spPr/>
+        <p:txBody>
+          <a:bodyPr/>
+          <a:lstStyle/>
+          <a:p>
+            <a:r>
+              <a:rPr lang="es-MX" dirty="0" smtClean="0"/>
+              <a:t>NEXT STEPS AND QUESTIONS</a:t>
+            </a:r>
+            <a:endParaRPr lang="en-US" dirty="0"/>
+          </a:p>
+        </p:txBody>
+      </p:sp>
+      <p:sp>
+        <p:nvSpPr>
+          <p:cNvPr id="3" name="Marcador de contenido 2"/>
+          <p:cNvSpPr>
+            <a:spLocks noGrp="1"/>
+          </p:cNvSpPr>
+          <p:nvPr>
+            <p:ph idx="1"/>
+          </p:nvPr>
+        </p:nvSpPr>
+        <p:spPr/>
+        <p:txBody>
+          <a:bodyPr>
+            <a:normAutofit/>
+          </a:bodyPr>
+          <a:lstStyle/>
+          <a:p>
+            <a:r>
+              <a:rPr lang="en-US" sz="2200" dirty="0" smtClean="0"/>
+              <a:t>Refining – how better integrate traits. PCA?</a:t>
+            </a:r>
+          </a:p>
+          <a:p>
+            <a:r>
+              <a:rPr lang="en-US" sz="2200" dirty="0" smtClean="0"/>
+              <a:t>The </a:t>
+            </a:r>
+            <a:r>
+              <a:rPr lang="en-US" sz="2200" dirty="0"/>
+              <a:t>experimental controls from 2009 (n = 9) would be used mainly as a baseline reference due to their limited sample size.</a:t>
+            </a:r>
+          </a:p>
+          <a:p>
+            <a:r>
+              <a:rPr lang="en-US" sz="2200" dirty="0"/>
+              <a:t>Regarding environmental drivers, elevation has been useful as an integrative gradient, but I would like to discuss the incorporation of explicit climatic variables to improve </a:t>
+            </a:r>
+            <a:r>
+              <a:rPr lang="en-US" sz="2200" dirty="0" smtClean="0"/>
+              <a:t>interpretability or TPI?. I thought on working with PCA dimensions. </a:t>
+            </a:r>
+          </a:p>
+          <a:p>
+            <a:endParaRPr lang="en-US" dirty="0"/>
+          </a:p>
+        </p:txBody>
+      </p:sp>
+    </p:spTree>
+    <p:extLst>
+      <p:ext uri="{BB962C8B-B14F-4D97-AF65-F5344CB8AC3E}">
+        <p14:creationId xmlns:p14="http://schemas.microsoft.com/office/powerpoint/2010/main" val="2759048454"/>
+      </p:ext>
+    </p:extLst>
+  </p:cSld>
+  <p:clrMapOvr>
+    <a:masterClrMapping/>
+  </p:clrMapOvr>
+  <p:timing>
+    <p:tnLst>
+      <p:par>
+        <p:cTn id="1" dur="indefinite" restart="never" nodeType="tmRoot"/>
+      </p:par>
+    </p:tnLst>
+  </p:timing>
+</p:sld>
+</file>
+
 <file path=ppt/slides/slide3.xml><?xml version="1.0" encoding="utf-8"?>
 <p:sld xmlns:a="http://schemas.openxmlformats.org/drawingml/2006/main" xmlns:r="http://schemas.openxmlformats.org/officeDocument/2006/relationships" xmlns:p="http://schemas.openxmlformats.org/presentationml/2006/main" show="0">
   <p:cSld>
@@ -20595,121 +19959,14 @@
   <p:clrMapOvr>
     <a:masterClrMapping/>
   </p:clrMapOvr>
-  <mc:AlternateContent xmlns:mc="http://schemas.openxmlformats.org/markup-compatibility/2006">
-    <mc:Choice xmlns:p14="http://schemas.microsoft.com/office/powerpoint/2010/main" Requires="p14">
+  <mc:AlternateContent xmlns:mc="http://schemas.openxmlformats.org/markup-compatibility/2006" xmlns:p14="http://schemas.microsoft.com/office/powerpoint/2010/main">
+    <mc:Choice Requires="p14">
       <p:transition spd="slow" p14:dur="2000"/>
     </mc:Choice>
-    <mc:Fallback>
+    <mc:Fallback xmlns="">
       <p:transition spd="slow"/>
     </mc:Fallback>
   </mc:AlternateContent>
-  <p:timing>
-    <p:tnLst>
-      <p:par>
-        <p:cTn id="1" dur="indefinite" restart="never" nodeType="tmRoot"/>
-      </p:par>
-    </p:tnLst>
-  </p:timing>
-</p:sld>
-</file>
-
-<file path=ppt/slides/slide30.xml><?xml version="1.0" encoding="utf-8"?>
-<p:sld xmlns:a="http://schemas.openxmlformats.org/drawingml/2006/main" xmlns:r="http://schemas.openxmlformats.org/officeDocument/2006/relationships" xmlns:p="http://schemas.openxmlformats.org/presentationml/2006/main">
-  <p:cSld>
-    <p:spTree>
-      <p:nvGrpSpPr>
-        <p:cNvPr id="1" name=""/>
-        <p:cNvGrpSpPr/>
-        <p:nvPr/>
-      </p:nvGrpSpPr>
-      <p:grpSpPr>
-        <a:xfrm>
-          <a:off x="0" y="0"/>
-          <a:ext cx="0" cy="0"/>
-          <a:chOff x="0" y="0"/>
-          <a:chExt cx="0" cy="0"/>
-        </a:xfrm>
-      </p:grpSpPr>
-      <p:sp>
-        <p:nvSpPr>
-          <p:cNvPr id="2" name="Título 1"/>
-          <p:cNvSpPr>
-            <a:spLocks noGrp="1"/>
-          </p:cNvSpPr>
-          <p:nvPr>
-            <p:ph type="title"/>
-          </p:nvPr>
-        </p:nvSpPr>
-        <p:spPr/>
-        <p:txBody>
-          <a:bodyPr/>
-          <a:lstStyle/>
-          <a:p>
-            <a:r>
-              <a:rPr lang="es-MX" dirty="0" smtClean="0"/>
-              <a:t>NEXT STEPS AND QUESTIONS</a:t>
-            </a:r>
-            <a:endParaRPr lang="en-US" dirty="0"/>
-          </a:p>
-        </p:txBody>
-      </p:sp>
-      <p:sp>
-        <p:nvSpPr>
-          <p:cNvPr id="3" name="Marcador de contenido 2"/>
-          <p:cNvSpPr>
-            <a:spLocks noGrp="1"/>
-          </p:cNvSpPr>
-          <p:nvPr>
-            <p:ph idx="1"/>
-          </p:nvPr>
-        </p:nvSpPr>
-        <p:spPr/>
-        <p:txBody>
-          <a:bodyPr>
-            <a:normAutofit/>
-          </a:bodyPr>
-          <a:lstStyle/>
-          <a:p>
-            <a:r>
-              <a:rPr lang="en-US" sz="2200" dirty="0" smtClean="0"/>
-              <a:t>Refining – how better integrate traits. PCA?</a:t>
-            </a:r>
-          </a:p>
-          <a:p>
-            <a:r>
-              <a:rPr lang="en-US" sz="2200" dirty="0" smtClean="0"/>
-              <a:t>The </a:t>
-            </a:r>
-            <a:r>
-              <a:rPr lang="en-US" sz="2200" dirty="0"/>
-              <a:t>experimental controls from 2009 (n = 9) would be used mainly as a baseline reference due to their limited sample size.</a:t>
-            </a:r>
-          </a:p>
-          <a:p>
-            <a:r>
-              <a:rPr lang="en-US" sz="2200" dirty="0"/>
-              <a:t>Regarding environmental drivers, elevation has been useful as an integrative gradient, but I would like to discuss the incorporation of explicit climatic variables to improve </a:t>
-            </a:r>
-            <a:r>
-              <a:rPr lang="en-US" sz="2200" dirty="0" smtClean="0"/>
-              <a:t>interpretability or TPI?. I thought on working with PCA dimensions. </a:t>
-            </a:r>
-          </a:p>
-          <a:p>
-            <a:endParaRPr lang="en-US" dirty="0"/>
-          </a:p>
-        </p:txBody>
-      </p:sp>
-    </p:spTree>
-    <p:extLst>
-      <p:ext uri="{BB962C8B-B14F-4D97-AF65-F5344CB8AC3E}">
-        <p14:creationId xmlns:p14="http://schemas.microsoft.com/office/powerpoint/2010/main" val="2759048454"/>
-      </p:ext>
-    </p:extLst>
-  </p:cSld>
-  <p:clrMapOvr>
-    <a:masterClrMapping/>
-  </p:clrMapOvr>
   <p:timing>
     <p:tnLst>
       <p:par>
@@ -20919,11 +20176,7 @@
             </a:r>
             <a:r>
               <a:rPr lang="es-MX" dirty="0" smtClean="0"/>
-              <a:t> </a:t>
-            </a:r>
-            <a:r>
-              <a:rPr lang="es-MX" dirty="0" smtClean="0"/>
-              <a:t>are </a:t>
+              <a:t> are </a:t>
             </a:r>
             <a:r>
               <a:rPr lang="es-MX" dirty="0" err="1" smtClean="0"/>
@@ -21013,7 +20266,6 @@
               <a:rPr lang="es-MX" dirty="0" smtClean="0"/>
               <a:t>)?</a:t>
             </a:r>
-            <a:endParaRPr lang="es-MX" dirty="0" smtClean="0"/>
           </a:p>
           <a:p>
             <a:pPr marL="0" indent="0">
@@ -21154,11 +20406,7 @@
             </a:r>
             <a:r>
               <a:rPr lang="es-MX" dirty="0" smtClean="0"/>
-              <a:t>)</a:t>
-            </a:r>
-            <a:r>
-              <a:rPr lang="es-MX" dirty="0" smtClean="0"/>
-              <a:t>.</a:t>
+              <a:t>).</a:t>
             </a:r>
           </a:p>
           <a:p>
@@ -21233,7 +20481,6 @@
               <a:rPr lang="es-MX" sz="2400" dirty="0" smtClean="0"/>
               <a:t> et al, 2016).</a:t>
             </a:r>
-            <a:endParaRPr lang="es-MX" sz="2400" dirty="0" smtClean="0"/>
           </a:p>
           <a:p>
             <a:pPr marL="0" indent="0" algn="just">
@@ -21293,13 +20540,8 @@
             </a:r>
             <a:r>
               <a:rPr lang="es-MX" dirty="0" smtClean="0"/>
-              <a:t>of dO18</a:t>
-            </a:r>
-            <a:r>
-              <a:rPr lang="es-MX" dirty="0" smtClean="0"/>
-              <a:t>.</a:t>
-            </a:r>
-            <a:endParaRPr lang="es-MX" dirty="0" smtClean="0"/>
+              <a:t>of dO18.</a:t>
+            </a:r>
           </a:p>
         </p:txBody>
       </p:sp>
@@ -22014,7 +21256,7 @@
                     <a:lstStyle/>
                     <a:p>
                       <a:r>
-                        <a:rPr lang="en-US">
+                        <a:rPr lang="en-US" dirty="0">
                           <a:effectLst/>
                         </a:rPr>
                         <a:t>3</a:t>
@@ -38849,11 +38091,11 @@
   <p:clrMapOvr>
     <a:masterClrMapping/>
   </p:clrMapOvr>
-  <mc:AlternateContent xmlns:mc="http://schemas.openxmlformats.org/markup-compatibility/2006">
-    <mc:Choice xmlns:p14="http://schemas.microsoft.com/office/powerpoint/2010/main" Requires="p14">
+  <mc:AlternateContent xmlns:mc="http://schemas.openxmlformats.org/markup-compatibility/2006" xmlns:p14="http://schemas.microsoft.com/office/powerpoint/2010/main">
+    <mc:Choice Requires="p14">
       <p:transition spd="slow" p14:dur="2000"/>
     </mc:Choice>
-    <mc:Fallback>
+    <mc:Fallback xmlns="">
       <p:transition spd="slow"/>
     </mc:Fallback>
   </mc:AlternateContent>
@@ -46433,11 +45675,11 @@
   <p:clrMapOvr>
     <a:masterClrMapping/>
   </p:clrMapOvr>
-  <mc:AlternateContent xmlns:mc="http://schemas.openxmlformats.org/markup-compatibility/2006">
-    <mc:Choice xmlns:p14="http://schemas.microsoft.com/office/powerpoint/2010/main" Requires="p14">
+  <mc:AlternateContent xmlns:mc="http://schemas.openxmlformats.org/markup-compatibility/2006" xmlns:p14="http://schemas.microsoft.com/office/powerpoint/2010/main">
+    <mc:Choice Requires="p14">
       <p:transition spd="slow" p14:dur="2000"/>
     </mc:Choice>
-    <mc:Fallback>
+    <mc:Fallback xmlns="">
       <p:transition spd="slow"/>
     </mc:Fallback>
   </mc:AlternateContent>

</xml_diff>

<commit_message>
cambios en outline, pptx, en script principal es que se añadieron los nutrientes de Bombuscaro
</commit_message>
<xml_diff>
--- a/NUMEX_pre_RStudio/NUMEX results.pptx
+++ b/NUMEX_pre_RStudio/NUMEX results.pptx
@@ -136,6 +136,47 @@
     </a:lvl9pPr>
   </p:defaultTextStyle>
   <p:extLst>
+    <p:ext uri="{521415D9-36F7-43E2-AB2F-B90AF26B5E84}">
+      <p14:sectionLst xmlns:p14="http://schemas.microsoft.com/office/powerpoint/2010/main">
+        <p14:section name="Sección predeterminada" id="{280FA906-43C6-4670-94C4-13E5EA7AB40E}">
+          <p14:sldIdLst>
+            <p14:sldId id="266"/>
+            <p14:sldId id="282"/>
+            <p14:sldId id="268"/>
+            <p14:sldId id="285"/>
+            <p14:sldId id="271"/>
+          </p14:sldIdLst>
+        </p14:section>
+        <p14:section name="Sección sin título" id="{595CF41D-8C0D-40C1-B144-596D817172A6}">
+          <p14:sldIdLst>
+            <p14:sldId id="292"/>
+            <p14:sldId id="291"/>
+            <p14:sldId id="283"/>
+            <p14:sldId id="269"/>
+            <p14:sldId id="272"/>
+            <p14:sldId id="259"/>
+            <p14:sldId id="287"/>
+            <p14:sldId id="284"/>
+            <p14:sldId id="261"/>
+            <p14:sldId id="260"/>
+            <p14:sldId id="273"/>
+            <p14:sldId id="274"/>
+            <p14:sldId id="275"/>
+            <p14:sldId id="288"/>
+            <p14:sldId id="276"/>
+            <p14:sldId id="277"/>
+            <p14:sldId id="281"/>
+            <p14:sldId id="278"/>
+            <p14:sldId id="289"/>
+            <p14:sldId id="290"/>
+            <p14:sldId id="270"/>
+            <p14:sldId id="257"/>
+            <p14:sldId id="256"/>
+            <p14:sldId id="280"/>
+          </p14:sldIdLst>
+        </p14:section>
+      </p14:sectionLst>
+    </p:ext>
     <p:ext uri="{EFAFB233-063F-42B5-8137-9DF3F51BA10A}">
       <p15:sldGuideLst xmlns:p15="http://schemas.microsoft.com/office/powerpoint/2012/main">
         <p15:guide id="1" orient="horz" pos="2160" userDrawn="1">
@@ -236,7 +277,7 @@
           <a:p>
             <a:fld id="{99ADAB2D-2438-4DAF-8EF0-78196AA5F544}" type="datetimeFigureOut">
               <a:rPr lang="en-US" smtClean="0"/>
-              <a:t>2/24/2026</a:t>
+              <a:t>3/1/2026</a:t>
             </a:fld>
             <a:endParaRPr lang="en-US"/>
           </a:p>
@@ -2791,7 +2832,7 @@
           <a:p>
             <a:fld id="{742CBFA1-BD22-4292-9851-D341668FFB9E}" type="datetimeFigureOut">
               <a:rPr lang="en-US" smtClean="0"/>
-              <a:t>2/24/2026</a:t>
+              <a:t>3/1/2026</a:t>
             </a:fld>
             <a:endParaRPr lang="en-US"/>
           </a:p>
@@ -2961,7 +3002,7 @@
           <a:p>
             <a:fld id="{742CBFA1-BD22-4292-9851-D341668FFB9E}" type="datetimeFigureOut">
               <a:rPr lang="en-US" smtClean="0"/>
-              <a:t>2/24/2026</a:t>
+              <a:t>3/1/2026</a:t>
             </a:fld>
             <a:endParaRPr lang="en-US"/>
           </a:p>
@@ -3141,7 +3182,7 @@
           <a:p>
             <a:fld id="{742CBFA1-BD22-4292-9851-D341668FFB9E}" type="datetimeFigureOut">
               <a:rPr lang="en-US" smtClean="0"/>
-              <a:t>2/24/2026</a:t>
+              <a:t>3/1/2026</a:t>
             </a:fld>
             <a:endParaRPr lang="en-US"/>
           </a:p>
@@ -3311,7 +3352,7 @@
           <a:p>
             <a:fld id="{742CBFA1-BD22-4292-9851-D341668FFB9E}" type="datetimeFigureOut">
               <a:rPr lang="en-US" smtClean="0"/>
-              <a:t>2/24/2026</a:t>
+              <a:t>3/1/2026</a:t>
             </a:fld>
             <a:endParaRPr lang="en-US"/>
           </a:p>
@@ -3557,7 +3598,7 @@
           <a:p>
             <a:fld id="{742CBFA1-BD22-4292-9851-D341668FFB9E}" type="datetimeFigureOut">
               <a:rPr lang="en-US" smtClean="0"/>
-              <a:t>2/24/2026</a:t>
+              <a:t>3/1/2026</a:t>
             </a:fld>
             <a:endParaRPr lang="en-US"/>
           </a:p>
@@ -3789,7 +3830,7 @@
           <a:p>
             <a:fld id="{742CBFA1-BD22-4292-9851-D341668FFB9E}" type="datetimeFigureOut">
               <a:rPr lang="en-US" smtClean="0"/>
-              <a:t>2/24/2026</a:t>
+              <a:t>3/1/2026</a:t>
             </a:fld>
             <a:endParaRPr lang="en-US"/>
           </a:p>
@@ -4156,7 +4197,7 @@
           <a:p>
             <a:fld id="{742CBFA1-BD22-4292-9851-D341668FFB9E}" type="datetimeFigureOut">
               <a:rPr lang="en-US" smtClean="0"/>
-              <a:t>2/24/2026</a:t>
+              <a:t>3/1/2026</a:t>
             </a:fld>
             <a:endParaRPr lang="en-US"/>
           </a:p>
@@ -4274,7 +4315,7 @@
           <a:p>
             <a:fld id="{742CBFA1-BD22-4292-9851-D341668FFB9E}" type="datetimeFigureOut">
               <a:rPr lang="en-US" smtClean="0"/>
-              <a:t>2/24/2026</a:t>
+              <a:t>3/1/2026</a:t>
             </a:fld>
             <a:endParaRPr lang="en-US"/>
           </a:p>
@@ -4369,7 +4410,7 @@
           <a:p>
             <a:fld id="{742CBFA1-BD22-4292-9851-D341668FFB9E}" type="datetimeFigureOut">
               <a:rPr lang="en-US" smtClean="0"/>
-              <a:t>2/24/2026</a:t>
+              <a:t>3/1/2026</a:t>
             </a:fld>
             <a:endParaRPr lang="en-US"/>
           </a:p>
@@ -4646,7 +4687,7 @@
           <a:p>
             <a:fld id="{742CBFA1-BD22-4292-9851-D341668FFB9E}" type="datetimeFigureOut">
               <a:rPr lang="en-US" smtClean="0"/>
-              <a:t>2/24/2026</a:t>
+              <a:t>3/1/2026</a:t>
             </a:fld>
             <a:endParaRPr lang="en-US"/>
           </a:p>
@@ -4899,7 +4940,7 @@
           <a:p>
             <a:fld id="{742CBFA1-BD22-4292-9851-D341668FFB9E}" type="datetimeFigureOut">
               <a:rPr lang="en-US" smtClean="0"/>
-              <a:t>2/24/2026</a:t>
+              <a:t>3/1/2026</a:t>
             </a:fld>
             <a:endParaRPr lang="en-US"/>
           </a:p>
@@ -5112,7 +5153,7 @@
           <a:p>
             <a:fld id="{742CBFA1-BD22-4292-9851-D341668FFB9E}" type="datetimeFigureOut">
               <a:rPr lang="en-US" smtClean="0"/>
-              <a:t>2/24/2026</a:t>
+              <a:t>3/1/2026</a:t>
             </a:fld>
             <a:endParaRPr lang="en-US"/>
           </a:p>
@@ -12994,8 +13035,8 @@
         </p:blipFill>
         <p:spPr>
           <a:xfrm>
-            <a:off x="5683523" y="949713"/>
-            <a:ext cx="6666667" cy="4114286"/>
+            <a:off x="8554065" y="934040"/>
+            <a:ext cx="5070495" cy="3129220"/>
           </a:xfrm>
           <a:prstGeom prst="rect">
             <a:avLst/>
@@ -13018,8 +13059,8 @@
         </p:blipFill>
         <p:spPr>
           <a:xfrm>
-            <a:off x="268657" y="1227190"/>
-            <a:ext cx="4845323" cy="3559332"/>
+            <a:off x="-158190" y="192955"/>
+            <a:ext cx="8521382" cy="6259732"/>
           </a:xfrm>
           <a:prstGeom prst="rect">
             <a:avLst/>

</xml_diff>